<commit_message>
am64x/am243x : docs : Update profinet documentation for 9.2 release
Fixes: PINDSW-8148

Signed-off-by: Prajith Jayarajan <prajith@ti.com>
</commit_message>
<xml_diff>
--- a/docs_src/docs/api_guide/images/images.pptx
+++ b/docs_src/docs/api_guide/images/images.pptx
@@ -254,7 +254,7 @@
           <a:p>
             <a:fld id="{4ADF24D4-082E-4F97-B9C4-E0764843ED08}" type="datetimeFigureOut">
               <a:rPr lang="en-US" smtClean="0"/>
-              <a:t>1/8/2024</a:t>
+              <a:t>9/13/2024</a:t>
             </a:fld>
             <a:endParaRPr lang="en-US"/>
           </a:p>
@@ -3845,7 +3845,7 @@
         </p:nvSpPr>
         <p:spPr>
           <a:xfrm>
-            <a:off x="2013589" y="2490666"/>
+            <a:off x="1853987" y="2494076"/>
             <a:ext cx="587485" cy="314308"/>
           </a:xfrm>
           <a:prstGeom prst="rect">
@@ -4377,18 +4377,15 @@
               <a:buNone/>
             </a:pPr>
             <a:r>
-              <a:rPr lang="en-US" sz="1125" spc="-1">
+              <a:rPr lang="en-US" sz="1125" spc="-1" dirty="0">
                 <a:solidFill>
                   <a:srgbClr val="000000"/>
                 </a:solidFill>
                 <a:latin typeface="Arial"/>
                 <a:ea typeface="DejaVu Sans"/>
               </a:rPr>
-              <a:t>Drivers and</a:t>
-            </a:r>
-            <a:endParaRPr lang="en-IN" sz="1125" spc="-1">
-              <a:latin typeface="Arial"/>
-            </a:endParaRPr>
+              <a:t>Drivers </a:t>
+            </a:r>
           </a:p>
           <a:p>
             <a:pPr>
@@ -4398,16 +4395,32 @@
               <a:buNone/>
             </a:pPr>
             <a:r>
-              <a:rPr lang="en-US" sz="1125" spc="-1">
+              <a:rPr lang="en-US" sz="1125" spc="-1" dirty="0">
                 <a:solidFill>
                   <a:srgbClr val="000000"/>
                 </a:solidFill>
                 <a:latin typeface="Arial"/>
                 <a:ea typeface="DejaVu Sans"/>
               </a:rPr>
+              <a:t>And</a:t>
+            </a:r>
+            <a:r>
+              <a:rPr lang="en-IN" sz="1125" spc="-1" dirty="0">
+                <a:latin typeface="Arial"/>
+              </a:rPr>
+              <a:t> </a:t>
+            </a:r>
+            <a:r>
+              <a:rPr lang="en-US" sz="1125" spc="-1" dirty="0">
+                <a:solidFill>
+                  <a:srgbClr val="000000"/>
+                </a:solidFill>
+                <a:latin typeface="Arial"/>
+                <a:ea typeface="DejaVu Sans"/>
+              </a:rPr>
               <a:t>HAL</a:t>
             </a:r>
-            <a:endParaRPr lang="en-IN" sz="1125" spc="-1">
+            <a:endParaRPr lang="en-IN" sz="1125" spc="-1" dirty="0">
               <a:latin typeface="Arial"/>
             </a:endParaRPr>
           </a:p>
@@ -4427,8 +4440,8 @@
         </p:nvSpPr>
         <p:spPr>
           <a:xfrm>
-            <a:off x="1397592" y="2481330"/>
-            <a:ext cx="587485" cy="313537"/>
+            <a:off x="1237834" y="2494494"/>
+            <a:ext cx="584480" cy="313537"/>
           </a:xfrm>
           <a:prstGeom prst="rect">
             <a:avLst/>
@@ -5335,8 +5348,8 @@
         </p:nvSpPr>
         <p:spPr>
           <a:xfrm>
-            <a:off x="3644727" y="2481330"/>
-            <a:ext cx="596853" cy="310587"/>
+            <a:off x="3486073" y="2484514"/>
+            <a:ext cx="579226" cy="310587"/>
           </a:xfrm>
           <a:prstGeom prst="rect">
             <a:avLst/>
@@ -5417,8 +5430,8 @@
         </p:nvSpPr>
         <p:spPr>
           <a:xfrm>
-            <a:off x="4289404" y="2490666"/>
-            <a:ext cx="598130" cy="315079"/>
+            <a:off x="4086752" y="2486694"/>
+            <a:ext cx="706460" cy="315079"/>
           </a:xfrm>
           <a:prstGeom prst="rect">
             <a:avLst/>
@@ -5499,7 +5512,7 @@
         </p:nvSpPr>
         <p:spPr>
           <a:xfrm>
-            <a:off x="5492957" y="2477660"/>
+            <a:off x="5533271" y="2489896"/>
             <a:ext cx="598130" cy="315079"/>
           </a:xfrm>
           <a:prstGeom prst="rect">
@@ -5845,7 +5858,7 @@
           <a:p>
             <a:pPr algn="ctr"/>
             <a:r>
-              <a:rPr lang="en-US" sz="800" spc="-1">
+              <a:rPr lang="en-US" sz="800" spc="-1" dirty="0" err="1">
                 <a:solidFill>
                   <a:srgbClr val="000000"/>
                 </a:solidFill>
@@ -5958,8 +5971,8 @@
         </p:nvSpPr>
         <p:spPr>
           <a:xfrm>
-            <a:off x="4913845" y="2477660"/>
-            <a:ext cx="552801" cy="310587"/>
+            <a:off x="4827394" y="2484515"/>
+            <a:ext cx="678441" cy="310587"/>
           </a:xfrm>
           <a:prstGeom prst="rect">
             <a:avLst/>
@@ -6000,20 +6013,14 @@
           <a:p>
             <a:pPr algn="ctr"/>
             <a:r>
-              <a:rPr lang="en-US" sz="800" spc="-1" dirty="0" err="1">
+              <a:rPr lang="en-US" sz="800" spc="-1" dirty="0">
                 <a:solidFill>
                   <a:srgbClr val="000000"/>
                 </a:solidFill>
                 <a:latin typeface="Arial"/>
               </a:rPr>
-              <a:t>Profinet</a:t>
-            </a:r>
-            <a:endParaRPr lang="en-US" sz="800" spc="-1" dirty="0">
-              <a:solidFill>
-                <a:srgbClr val="000000"/>
-              </a:solidFill>
-              <a:latin typeface="Arial"/>
-            </a:endParaRPr>
+              <a:t>PROFINET</a:t>
+            </a:r>
           </a:p>
           <a:p>
             <a:pPr algn="ctr"/>
@@ -6898,20 +6905,14 @@
           <a:p>
             <a:pPr algn="ctr"/>
             <a:r>
-              <a:rPr lang="en-IN" sz="800" spc="-1">
+              <a:rPr lang="en-IN" sz="800" spc="-1" dirty="0">
                 <a:solidFill>
                   <a:srgbClr val="000000"/>
                 </a:solidFill>
                 <a:latin typeface="Arial"/>
               </a:rPr>
-              <a:t>Profinet</a:t>
-            </a:r>
-            <a:endParaRPr lang="en-IN" sz="800" spc="-1" dirty="0">
-              <a:solidFill>
-                <a:srgbClr val="000000"/>
-              </a:solidFill>
-              <a:latin typeface="Arial"/>
-            </a:endParaRPr>
+              <a:t>PROFINET</a:t>
+            </a:r>
           </a:p>
         </p:txBody>
       </p:sp>
@@ -7078,7 +7079,7 @@
         </p:nvSpPr>
         <p:spPr>
           <a:xfrm>
-            <a:off x="3147633" y="2481061"/>
+            <a:off x="2975706" y="2494076"/>
             <a:ext cx="476185" cy="314308"/>
           </a:xfrm>
           <a:prstGeom prst="rect">
@@ -7364,8 +7365,8 @@
         </p:nvSpPr>
         <p:spPr>
           <a:xfrm>
-            <a:off x="2628525" y="2479540"/>
-            <a:ext cx="498200" cy="313537"/>
+            <a:off x="2469415" y="2494076"/>
+            <a:ext cx="473238" cy="330895"/>
           </a:xfrm>
           <a:prstGeom prst="rect">
             <a:avLst/>
@@ -9865,79 +9866,6 @@
       </p:sp>
       <p:sp>
         <p:nvSpPr>
-          <p:cNvPr id="95" name="CustomShape 4">
-            <a:extLst>
-              <a:ext uri="{FF2B5EF4-FFF2-40B4-BE49-F238E27FC236}">
-                <a16:creationId xmlns:a16="http://schemas.microsoft.com/office/drawing/2014/main" id="{EE1ED833-9B8E-42DE-862A-332B8BB6C59F}"/>
-              </a:ext>
-            </a:extLst>
-          </p:cNvPr>
-          <p:cNvSpPr/>
-          <p:nvPr/>
-        </p:nvSpPr>
-        <p:spPr>
-          <a:xfrm>
-            <a:off x="2013589" y="2490666"/>
-            <a:ext cx="587485" cy="314308"/>
-          </a:xfrm>
-          <a:prstGeom prst="rect">
-            <a:avLst/>
-          </a:prstGeom>
-          <a:solidFill>
-            <a:schemeClr val="bg2"/>
-          </a:solidFill>
-          <a:ln>
-            <a:noFill/>
-          </a:ln>
-          <a:effectLst>
-            <a:outerShdw blurRad="50760" dist="37674" dir="2700000" algn="tl" rotWithShape="0">
-              <a:srgbClr val="000000">
-                <a:alpha val="40000"/>
-              </a:srgbClr>
-            </a:outerShdw>
-          </a:effectLst>
-        </p:spPr>
-        <p:style>
-          <a:lnRef idx="2">
-            <a:schemeClr val="accent1">
-              <a:shade val="50000"/>
-            </a:schemeClr>
-          </a:lnRef>
-          <a:fillRef idx="1">
-            <a:schemeClr val="accent1"/>
-          </a:fillRef>
-          <a:effectRef idx="0">
-            <a:schemeClr val="accent1"/>
-          </a:effectRef>
-          <a:fontRef idx="minor"/>
-        </p:style>
-        <p:txBody>
-          <a:bodyPr lIns="56250" tIns="28125" rIns="56250" bIns="28125" anchor="ctr">
-            <a:noAutofit/>
-          </a:bodyPr>
-          <a:lstStyle/>
-          <a:p>
-            <a:pPr algn="ctr"/>
-            <a:r>
-              <a:rPr lang="en-US" sz="800" spc="-1" dirty="0">
-                <a:solidFill>
-                  <a:srgbClr val="FFFFFF"/>
-                </a:solidFill>
-                <a:latin typeface="Arial"/>
-              </a:rPr>
-              <a:t>SOC Peripheral</a:t>
-            </a:r>
-            <a:endParaRPr lang="en-IN" sz="800" spc="-1" dirty="0">
-              <a:solidFill>
-                <a:srgbClr val="FFFFFF"/>
-              </a:solidFill>
-              <a:latin typeface="Arial"/>
-            </a:endParaRPr>
-          </a:p>
-        </p:txBody>
-      </p:sp>
-      <p:sp>
-        <p:nvSpPr>
           <p:cNvPr id="96" name="CustomShape 5">
             <a:extLst>
               <a:ext uri="{FF2B5EF4-FFF2-40B4-BE49-F238E27FC236}">
@@ -10198,7 +10126,7 @@
         </p:nvSpPr>
         <p:spPr>
           <a:xfrm>
-            <a:off x="2877625" y="1139326"/>
+            <a:off x="2449638" y="1155590"/>
             <a:ext cx="677087" cy="281025"/>
           </a:xfrm>
           <a:prstGeom prst="rect">
@@ -10248,7 +10176,7 @@
               <a:t>EtherNet</a:t>
             </a:r>
             <a:r>
-              <a:rPr lang="en-US" sz="800" spc="-1">
+              <a:rPr lang="en-US" sz="800" spc="-1" dirty="0">
                 <a:solidFill>
                   <a:srgbClr val="000000"/>
                 </a:solidFill>
@@ -10356,170 +10284,6 @@
       </p:sp>
       <p:sp>
         <p:nvSpPr>
-          <p:cNvPr id="103" name="CustomShape 14">
-            <a:extLst>
-              <a:ext uri="{FF2B5EF4-FFF2-40B4-BE49-F238E27FC236}">
-                <a16:creationId xmlns:a16="http://schemas.microsoft.com/office/drawing/2014/main" id="{FCF98F88-D895-4FB6-B9A3-2730BEF3D422}"/>
-              </a:ext>
-            </a:extLst>
-          </p:cNvPr>
-          <p:cNvSpPr/>
-          <p:nvPr/>
-        </p:nvSpPr>
-        <p:spPr>
-          <a:xfrm>
-            <a:off x="585455" y="2361492"/>
-            <a:ext cx="5574783" cy="542925"/>
-          </a:xfrm>
-          <a:prstGeom prst="rect">
-            <a:avLst/>
-          </a:prstGeom>
-          <a:noFill/>
-          <a:ln>
-            <a:solidFill>
-              <a:srgbClr val="000000"/>
-            </a:solidFill>
-            <a:round/>
-          </a:ln>
-        </p:spPr>
-        <p:style>
-          <a:lnRef idx="2">
-            <a:schemeClr val="accent1">
-              <a:shade val="50000"/>
-            </a:schemeClr>
-          </a:lnRef>
-          <a:fillRef idx="1">
-            <a:schemeClr val="accent1"/>
-          </a:fillRef>
-          <a:effectRef idx="0">
-            <a:schemeClr val="accent1"/>
-          </a:effectRef>
-          <a:fontRef idx="minor"/>
-        </p:style>
-        <p:txBody>
-          <a:bodyPr lIns="56250" tIns="28125" rIns="56250" bIns="28125" anchor="ctr">
-            <a:noAutofit/>
-          </a:bodyPr>
-          <a:lstStyle/>
-          <a:p>
-            <a:pPr>
-              <a:lnSpc>
-                <a:spcPct val="100000"/>
-              </a:lnSpc>
-              <a:buNone/>
-            </a:pPr>
-            <a:r>
-              <a:rPr lang="en-US" sz="1125" spc="-1">
-                <a:solidFill>
-                  <a:srgbClr val="000000"/>
-                </a:solidFill>
-                <a:latin typeface="Arial"/>
-                <a:ea typeface="DejaVu Sans"/>
-              </a:rPr>
-              <a:t>Drivers and</a:t>
-            </a:r>
-            <a:endParaRPr lang="en-IN" sz="1125" spc="-1">
-              <a:latin typeface="Arial"/>
-            </a:endParaRPr>
-          </a:p>
-          <a:p>
-            <a:pPr>
-              <a:lnSpc>
-                <a:spcPct val="100000"/>
-              </a:lnSpc>
-              <a:buNone/>
-            </a:pPr>
-            <a:r>
-              <a:rPr lang="en-US" sz="1125" spc="-1">
-                <a:solidFill>
-                  <a:srgbClr val="000000"/>
-                </a:solidFill>
-                <a:latin typeface="Arial"/>
-                <a:ea typeface="DejaVu Sans"/>
-              </a:rPr>
-              <a:t>HAL</a:t>
-            </a:r>
-            <a:endParaRPr lang="en-IN" sz="1125" spc="-1">
-              <a:latin typeface="Arial"/>
-            </a:endParaRPr>
-          </a:p>
-        </p:txBody>
-      </p:sp>
-      <p:sp>
-        <p:nvSpPr>
-          <p:cNvPr id="104" name="CustomShape 15">
-            <a:extLst>
-              <a:ext uri="{FF2B5EF4-FFF2-40B4-BE49-F238E27FC236}">
-                <a16:creationId xmlns:a16="http://schemas.microsoft.com/office/drawing/2014/main" id="{380BEEDE-BBC0-49D0-A027-E0BDA8EF854B}"/>
-              </a:ext>
-            </a:extLst>
-          </p:cNvPr>
-          <p:cNvSpPr/>
-          <p:nvPr/>
-        </p:nvSpPr>
-        <p:spPr>
-          <a:xfrm>
-            <a:off x="1397592" y="2481330"/>
-            <a:ext cx="587485" cy="313537"/>
-          </a:xfrm>
-          <a:prstGeom prst="rect">
-            <a:avLst/>
-          </a:prstGeom>
-          <a:solidFill>
-            <a:schemeClr val="bg2"/>
-          </a:solidFill>
-          <a:ln>
-            <a:noFill/>
-          </a:ln>
-          <a:effectLst>
-            <a:outerShdw blurRad="50760" dist="37674" dir="2700000" algn="tl" rotWithShape="0">
-              <a:srgbClr val="000000">
-                <a:alpha val="40000"/>
-              </a:srgbClr>
-            </a:outerShdw>
-          </a:effectLst>
-        </p:spPr>
-        <p:style>
-          <a:lnRef idx="2">
-            <a:schemeClr val="accent1">
-              <a:shade val="50000"/>
-            </a:schemeClr>
-          </a:lnRef>
-          <a:fillRef idx="1">
-            <a:schemeClr val="accent1"/>
-          </a:fillRef>
-          <a:effectRef idx="0">
-            <a:schemeClr val="accent1"/>
-          </a:effectRef>
-          <a:fontRef idx="minor"/>
-        </p:style>
-        <p:txBody>
-          <a:bodyPr lIns="56250" tIns="28125" rIns="56250" bIns="28125" anchor="ctr">
-            <a:noAutofit/>
-          </a:bodyPr>
-          <a:lstStyle/>
-          <a:p>
-            <a:pPr algn="ctr"/>
-            <a:r>
-              <a:rPr lang="en-US" sz="800" spc="-1" dirty="0">
-                <a:solidFill>
-                  <a:srgbClr val="FFFFFF"/>
-                </a:solidFill>
-                <a:latin typeface="Arial"/>
-              </a:rPr>
-              <a:t>Board Peripheral</a:t>
-            </a:r>
-            <a:endParaRPr lang="en-IN" sz="800" spc="-1" dirty="0">
-              <a:solidFill>
-                <a:srgbClr val="FFFFFF"/>
-              </a:solidFill>
-              <a:latin typeface="Arial"/>
-            </a:endParaRPr>
-          </a:p>
-        </p:txBody>
-      </p:sp>
-      <p:sp>
-        <p:nvSpPr>
           <p:cNvPr id="105" name="CustomShape 16">
             <a:extLst>
               <a:ext uri="{FF2B5EF4-FFF2-40B4-BE49-F238E27FC236}">
@@ -11123,7 +10887,7 @@
         </p:nvSpPr>
         <p:spPr>
           <a:xfrm>
-            <a:off x="1985077" y="1147678"/>
+            <a:off x="1702917" y="1149825"/>
             <a:ext cx="677087" cy="281025"/>
           </a:xfrm>
           <a:prstGeom prst="rect">
@@ -11165,7 +10929,7 @@
           <a:p>
             <a:pPr algn="ctr"/>
             <a:r>
-              <a:rPr lang="en-US" sz="800" spc="-1">
+              <a:rPr lang="en-US" sz="800" spc="-1" dirty="0" err="1">
                 <a:solidFill>
                   <a:srgbClr val="000000"/>
                 </a:solidFill>
@@ -11337,246 +11101,6 @@
       </p:sp>
       <p:sp>
         <p:nvSpPr>
-          <p:cNvPr id="116" name="CustomShape 15">
-            <a:extLst>
-              <a:ext uri="{FF2B5EF4-FFF2-40B4-BE49-F238E27FC236}">
-                <a16:creationId xmlns:a16="http://schemas.microsoft.com/office/drawing/2014/main" id="{F6FC5D3D-7F8F-4A27-81E5-BD63D465D11E}"/>
-              </a:ext>
-            </a:extLst>
-          </p:cNvPr>
-          <p:cNvSpPr/>
-          <p:nvPr/>
-        </p:nvSpPr>
-        <p:spPr>
-          <a:xfrm>
-            <a:off x="3644727" y="2481330"/>
-            <a:ext cx="596853" cy="310587"/>
-          </a:xfrm>
-          <a:prstGeom prst="rect">
-            <a:avLst/>
-          </a:prstGeom>
-          <a:solidFill>
-            <a:srgbClr val="92D050"/>
-          </a:solidFill>
-          <a:ln>
-            <a:noFill/>
-          </a:ln>
-          <a:effectLst>
-            <a:outerShdw blurRad="50760" dist="37674" dir="2700000" algn="tl" rotWithShape="0">
-              <a:srgbClr val="000000">
-                <a:alpha val="40000"/>
-              </a:srgbClr>
-            </a:outerShdw>
-          </a:effectLst>
-        </p:spPr>
-        <p:style>
-          <a:lnRef idx="2">
-            <a:schemeClr val="accent1">
-              <a:shade val="50000"/>
-            </a:schemeClr>
-          </a:lnRef>
-          <a:fillRef idx="1">
-            <a:schemeClr val="accent1"/>
-          </a:fillRef>
-          <a:effectRef idx="0">
-            <a:schemeClr val="accent1"/>
-          </a:effectRef>
-          <a:fontRef idx="minor"/>
-        </p:style>
-        <p:txBody>
-          <a:bodyPr lIns="56250" tIns="28125" rIns="56250" bIns="28125" anchor="ctr">
-            <a:noAutofit/>
-          </a:bodyPr>
-          <a:lstStyle/>
-          <a:p>
-            <a:pPr algn="ctr"/>
-            <a:r>
-              <a:rPr lang="en-US" sz="800" spc="-1" dirty="0" err="1">
-                <a:solidFill>
-                  <a:srgbClr val="000000"/>
-                </a:solidFill>
-                <a:latin typeface="Arial"/>
-              </a:rPr>
-              <a:t>EtherCAT</a:t>
-            </a:r>
-            <a:r>
-              <a:rPr lang="en-US" sz="800" spc="-1" dirty="0">
-                <a:solidFill>
-                  <a:srgbClr val="000000"/>
-                </a:solidFill>
-                <a:latin typeface="Arial"/>
-              </a:rPr>
-              <a:t> FW HAL</a:t>
-            </a:r>
-            <a:endParaRPr lang="en-IN" sz="800" spc="-1" dirty="0">
-              <a:solidFill>
-                <a:srgbClr val="000000"/>
-              </a:solidFill>
-              <a:latin typeface="Arial"/>
-            </a:endParaRPr>
-          </a:p>
-        </p:txBody>
-      </p:sp>
-      <p:sp>
-        <p:nvSpPr>
-          <p:cNvPr id="117" name="CustomShape 15">
-            <a:extLst>
-              <a:ext uri="{FF2B5EF4-FFF2-40B4-BE49-F238E27FC236}">
-                <a16:creationId xmlns:a16="http://schemas.microsoft.com/office/drawing/2014/main" id="{72044023-059A-4FA2-830A-F4A2A114345F}"/>
-              </a:ext>
-            </a:extLst>
-          </p:cNvPr>
-          <p:cNvSpPr/>
-          <p:nvPr/>
-        </p:nvSpPr>
-        <p:spPr>
-          <a:xfrm>
-            <a:off x="4289404" y="2490666"/>
-            <a:ext cx="598130" cy="315079"/>
-          </a:xfrm>
-          <a:prstGeom prst="rect">
-            <a:avLst/>
-          </a:prstGeom>
-          <a:solidFill>
-            <a:srgbClr val="92D050"/>
-          </a:solidFill>
-          <a:ln>
-            <a:noFill/>
-          </a:ln>
-          <a:effectLst>
-            <a:outerShdw blurRad="50760" dist="37674" dir="2700000" algn="tl" rotWithShape="0">
-              <a:srgbClr val="000000">
-                <a:alpha val="40000"/>
-              </a:srgbClr>
-            </a:outerShdw>
-          </a:effectLst>
-        </p:spPr>
-        <p:style>
-          <a:lnRef idx="2">
-            <a:schemeClr val="accent1">
-              <a:shade val="50000"/>
-            </a:schemeClr>
-          </a:lnRef>
-          <a:fillRef idx="1">
-            <a:schemeClr val="accent1"/>
-          </a:fillRef>
-          <a:effectRef idx="0">
-            <a:schemeClr val="accent1"/>
-          </a:effectRef>
-          <a:fontRef idx="minor"/>
-        </p:style>
-        <p:txBody>
-          <a:bodyPr lIns="56250" tIns="28125" rIns="56250" bIns="28125" anchor="ctr">
-            <a:noAutofit/>
-          </a:bodyPr>
-          <a:lstStyle/>
-          <a:p>
-            <a:pPr algn="ctr"/>
-            <a:r>
-              <a:rPr lang="en-US" sz="800" spc="-1" dirty="0" err="1">
-                <a:solidFill>
-                  <a:srgbClr val="000000"/>
-                </a:solidFill>
-                <a:latin typeface="Arial"/>
-              </a:rPr>
-              <a:t>EtherNet</a:t>
-            </a:r>
-            <a:r>
-              <a:rPr lang="en-US" sz="800" spc="-1" dirty="0">
-                <a:solidFill>
-                  <a:srgbClr val="000000"/>
-                </a:solidFill>
-                <a:latin typeface="Arial"/>
-              </a:rPr>
-              <a:t>/IP FW HAL</a:t>
-            </a:r>
-            <a:endParaRPr lang="en-IN" sz="800" spc="-1" dirty="0">
-              <a:solidFill>
-                <a:srgbClr val="000000"/>
-              </a:solidFill>
-              <a:latin typeface="Arial"/>
-            </a:endParaRPr>
-          </a:p>
-        </p:txBody>
-      </p:sp>
-      <p:sp>
-        <p:nvSpPr>
-          <p:cNvPr id="118" name="CustomShape 15">
-            <a:extLst>
-              <a:ext uri="{FF2B5EF4-FFF2-40B4-BE49-F238E27FC236}">
-                <a16:creationId xmlns:a16="http://schemas.microsoft.com/office/drawing/2014/main" id="{19BA375C-0037-455C-9403-5FAD7F7FFC3C}"/>
-              </a:ext>
-            </a:extLst>
-          </p:cNvPr>
-          <p:cNvSpPr/>
-          <p:nvPr/>
-        </p:nvSpPr>
-        <p:spPr>
-          <a:xfrm>
-            <a:off x="5492957" y="2477660"/>
-            <a:ext cx="598130" cy="315079"/>
-          </a:xfrm>
-          <a:prstGeom prst="rect">
-            <a:avLst/>
-          </a:prstGeom>
-          <a:solidFill>
-            <a:srgbClr val="92D050"/>
-          </a:solidFill>
-          <a:ln>
-            <a:noFill/>
-          </a:ln>
-          <a:effectLst>
-            <a:outerShdw blurRad="50760" dist="37674" dir="2700000" algn="tl" rotWithShape="0">
-              <a:srgbClr val="000000">
-                <a:alpha val="40000"/>
-              </a:srgbClr>
-            </a:outerShdw>
-          </a:effectLst>
-        </p:spPr>
-        <p:style>
-          <a:lnRef idx="2">
-            <a:schemeClr val="accent1">
-              <a:shade val="50000"/>
-            </a:schemeClr>
-          </a:lnRef>
-          <a:fillRef idx="1">
-            <a:schemeClr val="accent1"/>
-          </a:fillRef>
-          <a:effectRef idx="0">
-            <a:schemeClr val="accent1"/>
-          </a:effectRef>
-          <a:fontRef idx="minor"/>
-        </p:style>
-        <p:txBody>
-          <a:bodyPr lIns="56250" tIns="28125" rIns="56250" bIns="28125" anchor="ctr">
-            <a:noAutofit/>
-          </a:bodyPr>
-          <a:lstStyle/>
-          <a:p>
-            <a:pPr algn="ctr">
-              <a:lnSpc>
-                <a:spcPct val="100000"/>
-              </a:lnSpc>
-              <a:buNone/>
-            </a:pPr>
-            <a:r>
-              <a:rPr lang="en-US" sz="800" spc="-1" dirty="0">
-                <a:solidFill>
-                  <a:srgbClr val="000000"/>
-                </a:solidFill>
-                <a:latin typeface="Arial"/>
-                <a:ea typeface="DejaVu Sans"/>
-              </a:rPr>
-              <a:t>HSR/PRP FW HAL</a:t>
-            </a:r>
-            <a:endParaRPr lang="en-IN" sz="800" spc="-1" dirty="0">
-              <a:latin typeface="Arial"/>
-            </a:endParaRPr>
-          </a:p>
-        </p:txBody>
-      </p:sp>
-      <p:sp>
-        <p:nvSpPr>
           <p:cNvPr id="122" name="CustomShape 13">
             <a:extLst>
               <a:ext uri="{FF2B5EF4-FFF2-40B4-BE49-F238E27FC236}">
@@ -11589,7 +11113,7 @@
         </p:nvSpPr>
         <p:spPr>
           <a:xfrm>
-            <a:off x="2441472" y="1837507"/>
+            <a:off x="2380004" y="1823794"/>
             <a:ext cx="660291" cy="261225"/>
           </a:xfrm>
           <a:prstGeom prst="rect">
@@ -11662,7 +11186,7 @@
         </p:nvSpPr>
         <p:spPr>
           <a:xfrm>
-            <a:off x="3199154" y="1835591"/>
+            <a:off x="3125631" y="1830504"/>
             <a:ext cx="661490" cy="261225"/>
           </a:xfrm>
           <a:prstGeom prst="rect">
@@ -11744,7 +11268,7 @@
         </p:nvSpPr>
         <p:spPr>
           <a:xfrm>
-            <a:off x="3956581" y="1844101"/>
+            <a:off x="3850135" y="1830504"/>
             <a:ext cx="501106" cy="261225"/>
           </a:xfrm>
           <a:prstGeom prst="rect">
@@ -11786,7 +11310,7 @@
           <a:p>
             <a:pPr algn="ctr"/>
             <a:r>
-              <a:rPr lang="en-US" sz="800" spc="-1">
+              <a:rPr lang="en-US" sz="800" spc="-1" dirty="0">
                 <a:solidFill>
                   <a:srgbClr val="000000"/>
                 </a:solidFill>
@@ -11817,8 +11341,8 @@
         </p:nvSpPr>
         <p:spPr>
           <a:xfrm>
-            <a:off x="4540797" y="1841166"/>
-            <a:ext cx="502610" cy="261225"/>
+            <a:off x="4414255" y="1841166"/>
+            <a:ext cx="627648" cy="255569"/>
           </a:xfrm>
           <a:prstGeom prst="rect">
             <a:avLst/>
@@ -11859,13 +11383,13 @@
           <a:p>
             <a:pPr algn="ctr"/>
             <a:r>
-              <a:rPr lang="en-US" sz="800" spc="-1">
+              <a:rPr lang="en-US" sz="800" spc="-1" dirty="0">
                 <a:solidFill>
                   <a:srgbClr val="000000"/>
                 </a:solidFill>
                 <a:latin typeface="Arial"/>
               </a:rPr>
-              <a:t>Profinet</a:t>
+              <a:t>PROFINET</a:t>
             </a:r>
             <a:endParaRPr lang="en-IN" sz="800" spc="-1" dirty="0">
               <a:solidFill>
@@ -11960,97 +11484,6 @@
       </p:sp>
       <p:sp>
         <p:nvSpPr>
-          <p:cNvPr id="129" name="CustomShape 15">
-            <a:extLst>
-              <a:ext uri="{FF2B5EF4-FFF2-40B4-BE49-F238E27FC236}">
-                <a16:creationId xmlns:a16="http://schemas.microsoft.com/office/drawing/2014/main" id="{2EBBEBDF-9CEF-4F01-838B-ADAC24958989}"/>
-              </a:ext>
-            </a:extLst>
-          </p:cNvPr>
-          <p:cNvSpPr/>
-          <p:nvPr/>
-        </p:nvSpPr>
-        <p:spPr>
-          <a:xfrm>
-            <a:off x="4913845" y="2477660"/>
-            <a:ext cx="552801" cy="310587"/>
-          </a:xfrm>
-          <a:prstGeom prst="rect">
-            <a:avLst/>
-          </a:prstGeom>
-          <a:solidFill>
-            <a:srgbClr val="92D050"/>
-          </a:solidFill>
-          <a:ln>
-            <a:noFill/>
-          </a:ln>
-          <a:effectLst>
-            <a:outerShdw blurRad="50760" dist="37674" dir="2700000" algn="tl" rotWithShape="0">
-              <a:srgbClr val="000000">
-                <a:alpha val="40000"/>
-              </a:srgbClr>
-            </a:outerShdw>
-          </a:effectLst>
-        </p:spPr>
-        <p:style>
-          <a:lnRef idx="2">
-            <a:schemeClr val="accent1">
-              <a:shade val="50000"/>
-            </a:schemeClr>
-          </a:lnRef>
-          <a:fillRef idx="1">
-            <a:schemeClr val="accent1"/>
-          </a:fillRef>
-          <a:effectRef idx="0">
-            <a:schemeClr val="accent1"/>
-          </a:effectRef>
-          <a:fontRef idx="minor"/>
-        </p:style>
-        <p:txBody>
-          <a:bodyPr lIns="56250" tIns="28125" rIns="56250" bIns="28125" anchor="ctr">
-            <a:noAutofit/>
-          </a:bodyPr>
-          <a:lstStyle/>
-          <a:p>
-            <a:pPr algn="ctr"/>
-            <a:r>
-              <a:rPr lang="en-US" sz="800" spc="-1" dirty="0" err="1">
-                <a:solidFill>
-                  <a:srgbClr val="000000"/>
-                </a:solidFill>
-                <a:latin typeface="Arial"/>
-              </a:rPr>
-              <a:t>Profinet</a:t>
-            </a:r>
-            <a:endParaRPr lang="en-US" sz="800" spc="-1" dirty="0">
-              <a:solidFill>
-                <a:srgbClr val="000000"/>
-              </a:solidFill>
-              <a:latin typeface="Arial"/>
-            </a:endParaRPr>
-          </a:p>
-          <a:p>
-            <a:pPr algn="ctr"/>
-            <a:r>
-              <a:rPr lang="en-US" sz="800" spc="-1" dirty="0">
-                <a:solidFill>
-                  <a:srgbClr val="000000"/>
-                </a:solidFill>
-                <a:latin typeface="Arial"/>
-              </a:rPr>
-              <a:t>FW HAL</a:t>
-            </a:r>
-            <a:endParaRPr lang="en-IN" sz="800" spc="-1" dirty="0">
-              <a:solidFill>
-                <a:srgbClr val="000000"/>
-              </a:solidFill>
-              <a:latin typeface="Arial"/>
-            </a:endParaRPr>
-          </a:p>
-        </p:txBody>
-      </p:sp>
-      <p:sp>
-        <p:nvSpPr>
           <p:cNvPr id="130" name="CustomShape 8">
             <a:extLst>
               <a:ext uri="{FF2B5EF4-FFF2-40B4-BE49-F238E27FC236}">
@@ -12063,7 +11496,7 @@
         </p:nvSpPr>
         <p:spPr>
           <a:xfrm>
-            <a:off x="4333137" y="1136468"/>
+            <a:off x="4443448" y="1138430"/>
             <a:ext cx="893130" cy="281025"/>
           </a:xfrm>
           <a:prstGeom prst="rect">
@@ -12693,20 +12126,14 @@
           <a:p>
             <a:pPr algn="ctr"/>
             <a:r>
-              <a:rPr lang="en-IN" sz="800" spc="-1">
+              <a:rPr lang="en-IN" sz="800" spc="-1" dirty="0">
                 <a:solidFill>
                   <a:srgbClr val="000000"/>
                 </a:solidFill>
                 <a:latin typeface="Arial"/>
               </a:rPr>
-              <a:t>Profinet</a:t>
-            </a:r>
-            <a:endParaRPr lang="en-IN" sz="800" spc="-1" dirty="0">
-              <a:solidFill>
-                <a:srgbClr val="000000"/>
-              </a:solidFill>
-              <a:latin typeface="Arial"/>
-            </a:endParaRPr>
+              <a:t>PROFINET</a:t>
+            </a:r>
           </a:p>
         </p:txBody>
       </p:sp>
@@ -12861,73 +12288,6 @@
       </p:sp>
       <p:sp>
         <p:nvSpPr>
-          <p:cNvPr id="53" name="CustomShape 4">
-            <a:extLst>
-              <a:ext uri="{FF2B5EF4-FFF2-40B4-BE49-F238E27FC236}">
-                <a16:creationId xmlns:a16="http://schemas.microsoft.com/office/drawing/2014/main" id="{97D896C7-D779-43E3-8EEB-18709C07EF68}"/>
-              </a:ext>
-            </a:extLst>
-          </p:cNvPr>
-          <p:cNvSpPr/>
-          <p:nvPr/>
-        </p:nvSpPr>
-        <p:spPr>
-          <a:xfrm>
-            <a:off x="3147633" y="2481061"/>
-            <a:ext cx="476185" cy="314308"/>
-          </a:xfrm>
-          <a:prstGeom prst="rect">
-            <a:avLst/>
-          </a:prstGeom>
-          <a:solidFill>
-            <a:srgbClr val="92D050"/>
-          </a:solidFill>
-          <a:ln>
-            <a:noFill/>
-          </a:ln>
-          <a:effectLst>
-            <a:outerShdw blurRad="50760" dist="37674" dir="2700000" algn="tl" rotWithShape="0">
-              <a:srgbClr val="000000">
-                <a:alpha val="40000"/>
-              </a:srgbClr>
-            </a:outerShdw>
-          </a:effectLst>
-        </p:spPr>
-        <p:style>
-          <a:lnRef idx="2">
-            <a:schemeClr val="accent1">
-              <a:shade val="50000"/>
-            </a:schemeClr>
-          </a:lnRef>
-          <a:fillRef idx="1">
-            <a:schemeClr val="accent1"/>
-          </a:fillRef>
-          <a:effectRef idx="0">
-            <a:schemeClr val="accent1"/>
-          </a:effectRef>
-          <a:fontRef idx="minor"/>
-        </p:style>
-        <p:txBody>
-          <a:bodyPr lIns="56250" tIns="28125" rIns="56250" bIns="28125" anchor="ctr">
-            <a:noAutofit/>
-          </a:bodyPr>
-          <a:lstStyle/>
-          <a:p>
-            <a:pPr algn="ctr"/>
-            <a:r>
-              <a:rPr lang="en-US" sz="800" spc="-1" dirty="0">
-                <a:latin typeface="Arial"/>
-              </a:rPr>
-              <a:t>ICSS EMAC</a:t>
-            </a:r>
-            <a:endParaRPr lang="en-IN" sz="800" spc="-1" dirty="0">
-              <a:latin typeface="Arial"/>
-            </a:endParaRPr>
-          </a:p>
-        </p:txBody>
-      </p:sp>
-      <p:sp>
-        <p:nvSpPr>
           <p:cNvPr id="60" name="CustomShape 8">
             <a:extLst>
               <a:ext uri="{FF2B5EF4-FFF2-40B4-BE49-F238E27FC236}">
@@ -12940,7 +12300,7 @@
         </p:nvSpPr>
         <p:spPr>
           <a:xfrm>
-            <a:off x="3727323" y="1140715"/>
+            <a:off x="3178613" y="1159337"/>
             <a:ext cx="501076" cy="281025"/>
           </a:xfrm>
           <a:prstGeom prst="rect">
@@ -13000,10 +12360,10 @@
       </p:sp>
       <p:sp>
         <p:nvSpPr>
-          <p:cNvPr id="59" name="CustomShape 15">
+          <p:cNvPr id="48" name="CustomShape 13">
             <a:extLst>
               <a:ext uri="{FF2B5EF4-FFF2-40B4-BE49-F238E27FC236}">
-                <a16:creationId xmlns:a16="http://schemas.microsoft.com/office/drawing/2014/main" id="{27C412CF-A645-442A-A325-31275374C607}"/>
+                <a16:creationId xmlns:a16="http://schemas.microsoft.com/office/drawing/2014/main" id="{E677CD8D-C283-486B-81B1-842CA395B0FC}"/>
               </a:ext>
             </a:extLst>
           </p:cNvPr>
@@ -13012,8 +12372,723 @@
         </p:nvSpPr>
         <p:spPr>
           <a:xfrm>
-            <a:off x="2628525" y="2479540"/>
-            <a:ext cx="498200" cy="313537"/>
+            <a:off x="3748433" y="1146963"/>
+            <a:ext cx="628486" cy="281025"/>
+          </a:xfrm>
+          <a:prstGeom prst="rect">
+            <a:avLst/>
+          </a:prstGeom>
+          <a:solidFill>
+            <a:srgbClr val="92D050"/>
+          </a:solidFill>
+          <a:ln>
+            <a:noFill/>
+          </a:ln>
+          <a:effectLst>
+            <a:outerShdw blurRad="50760" dist="37674" dir="2700000" algn="tl" rotWithShape="0">
+              <a:srgbClr val="000000">
+                <a:alpha val="40000"/>
+              </a:srgbClr>
+            </a:outerShdw>
+          </a:effectLst>
+        </p:spPr>
+        <p:style>
+          <a:lnRef idx="2">
+            <a:schemeClr val="accent1">
+              <a:shade val="50000"/>
+            </a:schemeClr>
+          </a:lnRef>
+          <a:fillRef idx="1">
+            <a:schemeClr val="accent1"/>
+          </a:fillRef>
+          <a:effectRef idx="0">
+            <a:schemeClr val="accent1"/>
+          </a:effectRef>
+          <a:fontRef idx="minor"/>
+        </p:style>
+        <p:txBody>
+          <a:bodyPr lIns="56250" tIns="28125" rIns="56250" bIns="28125" anchor="ctr">
+            <a:noAutofit/>
+          </a:bodyPr>
+          <a:lstStyle/>
+          <a:p>
+            <a:pPr algn="ctr"/>
+            <a:r>
+              <a:rPr lang="en-US" sz="800" spc="-1" dirty="0">
+                <a:solidFill>
+                  <a:srgbClr val="000000"/>
+                </a:solidFill>
+                <a:latin typeface="Arial"/>
+              </a:rPr>
+              <a:t>PROFINET</a:t>
+            </a:r>
+            <a:endParaRPr lang="en-IN" sz="800" spc="-1" dirty="0">
+              <a:solidFill>
+                <a:srgbClr val="000000"/>
+              </a:solidFill>
+              <a:latin typeface="Arial"/>
+            </a:endParaRPr>
+          </a:p>
+        </p:txBody>
+      </p:sp>
+      <p:sp>
+        <p:nvSpPr>
+          <p:cNvPr id="49" name="CustomShape 4">
+            <a:extLst>
+              <a:ext uri="{FF2B5EF4-FFF2-40B4-BE49-F238E27FC236}">
+                <a16:creationId xmlns:a16="http://schemas.microsoft.com/office/drawing/2014/main" id="{14FA41DA-0494-4870-B5A4-B6D29DA9CC76}"/>
+              </a:ext>
+            </a:extLst>
+          </p:cNvPr>
+          <p:cNvSpPr/>
+          <p:nvPr/>
+        </p:nvSpPr>
+        <p:spPr>
+          <a:xfrm>
+            <a:off x="1853987" y="2494076"/>
+            <a:ext cx="587485" cy="314308"/>
+          </a:xfrm>
+          <a:prstGeom prst="rect">
+            <a:avLst/>
+          </a:prstGeom>
+          <a:solidFill>
+            <a:schemeClr val="bg2"/>
+          </a:solidFill>
+          <a:ln>
+            <a:noFill/>
+          </a:ln>
+          <a:effectLst>
+            <a:outerShdw blurRad="50760" dist="37674" dir="2700000" algn="tl" rotWithShape="0">
+              <a:srgbClr val="000000">
+                <a:alpha val="40000"/>
+              </a:srgbClr>
+            </a:outerShdw>
+          </a:effectLst>
+        </p:spPr>
+        <p:style>
+          <a:lnRef idx="2">
+            <a:schemeClr val="accent1">
+              <a:shade val="50000"/>
+            </a:schemeClr>
+          </a:lnRef>
+          <a:fillRef idx="1">
+            <a:schemeClr val="accent1"/>
+          </a:fillRef>
+          <a:effectRef idx="0">
+            <a:schemeClr val="accent1"/>
+          </a:effectRef>
+          <a:fontRef idx="minor"/>
+        </p:style>
+        <p:txBody>
+          <a:bodyPr lIns="56250" tIns="28125" rIns="56250" bIns="28125" anchor="ctr">
+            <a:noAutofit/>
+          </a:bodyPr>
+          <a:lstStyle/>
+          <a:p>
+            <a:pPr algn="ctr"/>
+            <a:r>
+              <a:rPr lang="en-US" sz="800" spc="-1" dirty="0">
+                <a:solidFill>
+                  <a:srgbClr val="FFFFFF"/>
+                </a:solidFill>
+                <a:latin typeface="Arial"/>
+              </a:rPr>
+              <a:t>SOC Peripheral</a:t>
+            </a:r>
+            <a:endParaRPr lang="en-IN" sz="800" spc="-1" dirty="0">
+              <a:solidFill>
+                <a:srgbClr val="FFFFFF"/>
+              </a:solidFill>
+              <a:latin typeface="Arial"/>
+            </a:endParaRPr>
+          </a:p>
+        </p:txBody>
+      </p:sp>
+      <p:sp>
+        <p:nvSpPr>
+          <p:cNvPr id="50" name="CustomShape 14">
+            <a:extLst>
+              <a:ext uri="{FF2B5EF4-FFF2-40B4-BE49-F238E27FC236}">
+                <a16:creationId xmlns:a16="http://schemas.microsoft.com/office/drawing/2014/main" id="{5FC96578-D79B-445A-A1D8-8A8FE1947032}"/>
+              </a:ext>
+            </a:extLst>
+          </p:cNvPr>
+          <p:cNvSpPr/>
+          <p:nvPr/>
+        </p:nvSpPr>
+        <p:spPr>
+          <a:xfrm>
+            <a:off x="585455" y="2361492"/>
+            <a:ext cx="5574783" cy="542925"/>
+          </a:xfrm>
+          <a:prstGeom prst="rect">
+            <a:avLst/>
+          </a:prstGeom>
+          <a:noFill/>
+          <a:ln>
+            <a:solidFill>
+              <a:srgbClr val="000000"/>
+            </a:solidFill>
+            <a:round/>
+          </a:ln>
+        </p:spPr>
+        <p:style>
+          <a:lnRef idx="2">
+            <a:schemeClr val="accent1">
+              <a:shade val="50000"/>
+            </a:schemeClr>
+          </a:lnRef>
+          <a:fillRef idx="1">
+            <a:schemeClr val="accent1"/>
+          </a:fillRef>
+          <a:effectRef idx="0">
+            <a:schemeClr val="accent1"/>
+          </a:effectRef>
+          <a:fontRef idx="minor"/>
+        </p:style>
+        <p:txBody>
+          <a:bodyPr lIns="56250" tIns="28125" rIns="56250" bIns="28125" anchor="ctr">
+            <a:noAutofit/>
+          </a:bodyPr>
+          <a:lstStyle/>
+          <a:p>
+            <a:pPr>
+              <a:lnSpc>
+                <a:spcPct val="100000"/>
+              </a:lnSpc>
+              <a:buNone/>
+            </a:pPr>
+            <a:r>
+              <a:rPr lang="en-US" sz="1125" spc="-1" dirty="0">
+                <a:solidFill>
+                  <a:srgbClr val="000000"/>
+                </a:solidFill>
+                <a:latin typeface="Arial"/>
+                <a:ea typeface="DejaVu Sans"/>
+              </a:rPr>
+              <a:t>Drivers </a:t>
+            </a:r>
+          </a:p>
+          <a:p>
+            <a:pPr>
+              <a:lnSpc>
+                <a:spcPct val="100000"/>
+              </a:lnSpc>
+              <a:buNone/>
+            </a:pPr>
+            <a:r>
+              <a:rPr lang="en-US" sz="1125" spc="-1" dirty="0">
+                <a:solidFill>
+                  <a:srgbClr val="000000"/>
+                </a:solidFill>
+                <a:latin typeface="Arial"/>
+                <a:ea typeface="DejaVu Sans"/>
+              </a:rPr>
+              <a:t>And</a:t>
+            </a:r>
+            <a:r>
+              <a:rPr lang="en-IN" sz="1125" spc="-1" dirty="0">
+                <a:latin typeface="Arial"/>
+              </a:rPr>
+              <a:t> </a:t>
+            </a:r>
+            <a:r>
+              <a:rPr lang="en-US" sz="1125" spc="-1" dirty="0">
+                <a:solidFill>
+                  <a:srgbClr val="000000"/>
+                </a:solidFill>
+                <a:latin typeface="Arial"/>
+                <a:ea typeface="DejaVu Sans"/>
+              </a:rPr>
+              <a:t>HAL</a:t>
+            </a:r>
+            <a:endParaRPr lang="en-IN" sz="1125" spc="-1" dirty="0">
+              <a:latin typeface="Arial"/>
+            </a:endParaRPr>
+          </a:p>
+        </p:txBody>
+      </p:sp>
+      <p:sp>
+        <p:nvSpPr>
+          <p:cNvPr id="51" name="CustomShape 15">
+            <a:extLst>
+              <a:ext uri="{FF2B5EF4-FFF2-40B4-BE49-F238E27FC236}">
+                <a16:creationId xmlns:a16="http://schemas.microsoft.com/office/drawing/2014/main" id="{CCEE26B7-4B85-4CCD-A6E4-26E89EDBE7F3}"/>
+              </a:ext>
+            </a:extLst>
+          </p:cNvPr>
+          <p:cNvSpPr/>
+          <p:nvPr/>
+        </p:nvSpPr>
+        <p:spPr>
+          <a:xfrm>
+            <a:off x="1237834" y="2494494"/>
+            <a:ext cx="584480" cy="313537"/>
+          </a:xfrm>
+          <a:prstGeom prst="rect">
+            <a:avLst/>
+          </a:prstGeom>
+          <a:solidFill>
+            <a:schemeClr val="bg2"/>
+          </a:solidFill>
+          <a:ln>
+            <a:noFill/>
+          </a:ln>
+          <a:effectLst>
+            <a:outerShdw blurRad="50760" dist="37674" dir="2700000" algn="tl" rotWithShape="0">
+              <a:srgbClr val="000000">
+                <a:alpha val="40000"/>
+              </a:srgbClr>
+            </a:outerShdw>
+          </a:effectLst>
+        </p:spPr>
+        <p:style>
+          <a:lnRef idx="2">
+            <a:schemeClr val="accent1">
+              <a:shade val="50000"/>
+            </a:schemeClr>
+          </a:lnRef>
+          <a:fillRef idx="1">
+            <a:schemeClr val="accent1"/>
+          </a:fillRef>
+          <a:effectRef idx="0">
+            <a:schemeClr val="accent1"/>
+          </a:effectRef>
+          <a:fontRef idx="minor"/>
+        </p:style>
+        <p:txBody>
+          <a:bodyPr lIns="56250" tIns="28125" rIns="56250" bIns="28125" anchor="ctr">
+            <a:noAutofit/>
+          </a:bodyPr>
+          <a:lstStyle/>
+          <a:p>
+            <a:pPr algn="ctr"/>
+            <a:r>
+              <a:rPr lang="en-US" sz="800" spc="-1" dirty="0">
+                <a:solidFill>
+                  <a:srgbClr val="FFFFFF"/>
+                </a:solidFill>
+                <a:latin typeface="Arial"/>
+              </a:rPr>
+              <a:t>Board Peripheral</a:t>
+            </a:r>
+            <a:endParaRPr lang="en-IN" sz="800" spc="-1" dirty="0">
+              <a:solidFill>
+                <a:srgbClr val="FFFFFF"/>
+              </a:solidFill>
+              <a:latin typeface="Arial"/>
+            </a:endParaRPr>
+          </a:p>
+        </p:txBody>
+      </p:sp>
+      <p:sp>
+        <p:nvSpPr>
+          <p:cNvPr id="61" name="CustomShape 15">
+            <a:extLst>
+              <a:ext uri="{FF2B5EF4-FFF2-40B4-BE49-F238E27FC236}">
+                <a16:creationId xmlns:a16="http://schemas.microsoft.com/office/drawing/2014/main" id="{178C8F17-0652-4685-8891-8E108EA3F22B}"/>
+              </a:ext>
+            </a:extLst>
+          </p:cNvPr>
+          <p:cNvSpPr/>
+          <p:nvPr/>
+        </p:nvSpPr>
+        <p:spPr>
+          <a:xfrm>
+            <a:off x="3486073" y="2484514"/>
+            <a:ext cx="579226" cy="310587"/>
+          </a:xfrm>
+          <a:prstGeom prst="rect">
+            <a:avLst/>
+          </a:prstGeom>
+          <a:solidFill>
+            <a:srgbClr val="92D050"/>
+          </a:solidFill>
+          <a:ln>
+            <a:noFill/>
+          </a:ln>
+          <a:effectLst>
+            <a:outerShdw blurRad="50760" dist="37674" dir="2700000" algn="tl" rotWithShape="0">
+              <a:srgbClr val="000000">
+                <a:alpha val="40000"/>
+              </a:srgbClr>
+            </a:outerShdw>
+          </a:effectLst>
+        </p:spPr>
+        <p:style>
+          <a:lnRef idx="2">
+            <a:schemeClr val="accent1">
+              <a:shade val="50000"/>
+            </a:schemeClr>
+          </a:lnRef>
+          <a:fillRef idx="1">
+            <a:schemeClr val="accent1"/>
+          </a:fillRef>
+          <a:effectRef idx="0">
+            <a:schemeClr val="accent1"/>
+          </a:effectRef>
+          <a:fontRef idx="minor"/>
+        </p:style>
+        <p:txBody>
+          <a:bodyPr lIns="56250" tIns="28125" rIns="56250" bIns="28125" anchor="ctr">
+            <a:noAutofit/>
+          </a:bodyPr>
+          <a:lstStyle/>
+          <a:p>
+            <a:pPr algn="ctr"/>
+            <a:r>
+              <a:rPr lang="en-US" sz="800" spc="-1" dirty="0" err="1">
+                <a:solidFill>
+                  <a:srgbClr val="000000"/>
+                </a:solidFill>
+                <a:latin typeface="Arial"/>
+              </a:rPr>
+              <a:t>EtherCAT</a:t>
+            </a:r>
+            <a:r>
+              <a:rPr lang="en-US" sz="800" spc="-1" dirty="0">
+                <a:solidFill>
+                  <a:srgbClr val="000000"/>
+                </a:solidFill>
+                <a:latin typeface="Arial"/>
+              </a:rPr>
+              <a:t> FW HAL</a:t>
+            </a:r>
+            <a:endParaRPr lang="en-IN" sz="800" spc="-1" dirty="0">
+              <a:solidFill>
+                <a:srgbClr val="000000"/>
+              </a:solidFill>
+              <a:latin typeface="Arial"/>
+            </a:endParaRPr>
+          </a:p>
+        </p:txBody>
+      </p:sp>
+      <p:sp>
+        <p:nvSpPr>
+          <p:cNvPr id="62" name="CustomShape 15">
+            <a:extLst>
+              <a:ext uri="{FF2B5EF4-FFF2-40B4-BE49-F238E27FC236}">
+                <a16:creationId xmlns:a16="http://schemas.microsoft.com/office/drawing/2014/main" id="{4B6A03C8-4A8F-4F65-B513-E20BC5D52585}"/>
+              </a:ext>
+            </a:extLst>
+          </p:cNvPr>
+          <p:cNvSpPr/>
+          <p:nvPr/>
+        </p:nvSpPr>
+        <p:spPr>
+          <a:xfrm>
+            <a:off x="4086752" y="2486694"/>
+            <a:ext cx="706460" cy="315079"/>
+          </a:xfrm>
+          <a:prstGeom prst="rect">
+            <a:avLst/>
+          </a:prstGeom>
+          <a:solidFill>
+            <a:srgbClr val="92D050"/>
+          </a:solidFill>
+          <a:ln>
+            <a:noFill/>
+          </a:ln>
+          <a:effectLst>
+            <a:outerShdw blurRad="50760" dist="37674" dir="2700000" algn="tl" rotWithShape="0">
+              <a:srgbClr val="000000">
+                <a:alpha val="40000"/>
+              </a:srgbClr>
+            </a:outerShdw>
+          </a:effectLst>
+        </p:spPr>
+        <p:style>
+          <a:lnRef idx="2">
+            <a:schemeClr val="accent1">
+              <a:shade val="50000"/>
+            </a:schemeClr>
+          </a:lnRef>
+          <a:fillRef idx="1">
+            <a:schemeClr val="accent1"/>
+          </a:fillRef>
+          <a:effectRef idx="0">
+            <a:schemeClr val="accent1"/>
+          </a:effectRef>
+          <a:fontRef idx="minor"/>
+        </p:style>
+        <p:txBody>
+          <a:bodyPr lIns="56250" tIns="28125" rIns="56250" bIns="28125" anchor="ctr">
+            <a:noAutofit/>
+          </a:bodyPr>
+          <a:lstStyle/>
+          <a:p>
+            <a:pPr algn="ctr"/>
+            <a:r>
+              <a:rPr lang="en-US" sz="800" spc="-1" dirty="0" err="1">
+                <a:solidFill>
+                  <a:srgbClr val="000000"/>
+                </a:solidFill>
+                <a:latin typeface="Arial"/>
+              </a:rPr>
+              <a:t>EtherNet</a:t>
+            </a:r>
+            <a:r>
+              <a:rPr lang="en-US" sz="800" spc="-1" dirty="0">
+                <a:solidFill>
+                  <a:srgbClr val="000000"/>
+                </a:solidFill>
+                <a:latin typeface="Arial"/>
+              </a:rPr>
+              <a:t>/IP FW HAL</a:t>
+            </a:r>
+            <a:endParaRPr lang="en-IN" sz="800" spc="-1" dirty="0">
+              <a:solidFill>
+                <a:srgbClr val="000000"/>
+              </a:solidFill>
+              <a:latin typeface="Arial"/>
+            </a:endParaRPr>
+          </a:p>
+        </p:txBody>
+      </p:sp>
+      <p:sp>
+        <p:nvSpPr>
+          <p:cNvPr id="63" name="CustomShape 15">
+            <a:extLst>
+              <a:ext uri="{FF2B5EF4-FFF2-40B4-BE49-F238E27FC236}">
+                <a16:creationId xmlns:a16="http://schemas.microsoft.com/office/drawing/2014/main" id="{8241264A-5F1F-44F7-91FC-AFCE8DC4ABCC}"/>
+              </a:ext>
+            </a:extLst>
+          </p:cNvPr>
+          <p:cNvSpPr/>
+          <p:nvPr/>
+        </p:nvSpPr>
+        <p:spPr>
+          <a:xfrm>
+            <a:off x="5533271" y="2489896"/>
+            <a:ext cx="598130" cy="315079"/>
+          </a:xfrm>
+          <a:prstGeom prst="rect">
+            <a:avLst/>
+          </a:prstGeom>
+          <a:solidFill>
+            <a:srgbClr val="92D050"/>
+          </a:solidFill>
+          <a:ln>
+            <a:noFill/>
+          </a:ln>
+          <a:effectLst>
+            <a:outerShdw blurRad="50760" dist="37674" dir="2700000" algn="tl" rotWithShape="0">
+              <a:srgbClr val="000000">
+                <a:alpha val="40000"/>
+              </a:srgbClr>
+            </a:outerShdw>
+          </a:effectLst>
+        </p:spPr>
+        <p:style>
+          <a:lnRef idx="2">
+            <a:schemeClr val="accent1">
+              <a:shade val="50000"/>
+            </a:schemeClr>
+          </a:lnRef>
+          <a:fillRef idx="1">
+            <a:schemeClr val="accent1"/>
+          </a:fillRef>
+          <a:effectRef idx="0">
+            <a:schemeClr val="accent1"/>
+          </a:effectRef>
+          <a:fontRef idx="minor"/>
+        </p:style>
+        <p:txBody>
+          <a:bodyPr lIns="56250" tIns="28125" rIns="56250" bIns="28125" anchor="ctr">
+            <a:noAutofit/>
+          </a:bodyPr>
+          <a:lstStyle/>
+          <a:p>
+            <a:pPr algn="ctr">
+              <a:lnSpc>
+                <a:spcPct val="100000"/>
+              </a:lnSpc>
+              <a:buNone/>
+            </a:pPr>
+            <a:r>
+              <a:rPr lang="en-US" sz="800" spc="-1" dirty="0">
+                <a:solidFill>
+                  <a:srgbClr val="000000"/>
+                </a:solidFill>
+                <a:latin typeface="Arial"/>
+                <a:ea typeface="DejaVu Sans"/>
+              </a:rPr>
+              <a:t>HSR/PRP FW HAL</a:t>
+            </a:r>
+            <a:endParaRPr lang="en-IN" sz="800" spc="-1" dirty="0">
+              <a:latin typeface="Arial"/>
+            </a:endParaRPr>
+          </a:p>
+        </p:txBody>
+      </p:sp>
+      <p:sp>
+        <p:nvSpPr>
+          <p:cNvPr id="64" name="CustomShape 15">
+            <a:extLst>
+              <a:ext uri="{FF2B5EF4-FFF2-40B4-BE49-F238E27FC236}">
+                <a16:creationId xmlns:a16="http://schemas.microsoft.com/office/drawing/2014/main" id="{48498039-2E11-4029-916B-A89907CFA73D}"/>
+              </a:ext>
+            </a:extLst>
+          </p:cNvPr>
+          <p:cNvSpPr/>
+          <p:nvPr/>
+        </p:nvSpPr>
+        <p:spPr>
+          <a:xfrm>
+            <a:off x="4827394" y="2484515"/>
+            <a:ext cx="678441" cy="310587"/>
+          </a:xfrm>
+          <a:prstGeom prst="rect">
+            <a:avLst/>
+          </a:prstGeom>
+          <a:solidFill>
+            <a:srgbClr val="92D050"/>
+          </a:solidFill>
+          <a:ln>
+            <a:noFill/>
+          </a:ln>
+          <a:effectLst>
+            <a:outerShdw blurRad="50760" dist="37674" dir="2700000" algn="tl" rotWithShape="0">
+              <a:srgbClr val="000000">
+                <a:alpha val="40000"/>
+              </a:srgbClr>
+            </a:outerShdw>
+          </a:effectLst>
+        </p:spPr>
+        <p:style>
+          <a:lnRef idx="2">
+            <a:schemeClr val="accent1">
+              <a:shade val="50000"/>
+            </a:schemeClr>
+          </a:lnRef>
+          <a:fillRef idx="1">
+            <a:schemeClr val="accent1"/>
+          </a:fillRef>
+          <a:effectRef idx="0">
+            <a:schemeClr val="accent1"/>
+          </a:effectRef>
+          <a:fontRef idx="minor"/>
+        </p:style>
+        <p:txBody>
+          <a:bodyPr lIns="56250" tIns="28125" rIns="56250" bIns="28125" anchor="ctr">
+            <a:noAutofit/>
+          </a:bodyPr>
+          <a:lstStyle/>
+          <a:p>
+            <a:pPr algn="ctr"/>
+            <a:r>
+              <a:rPr lang="en-US" sz="800" spc="-1" dirty="0">
+                <a:solidFill>
+                  <a:srgbClr val="000000"/>
+                </a:solidFill>
+                <a:latin typeface="Arial"/>
+              </a:rPr>
+              <a:t>PROFINET</a:t>
+            </a:r>
+          </a:p>
+          <a:p>
+            <a:pPr algn="ctr"/>
+            <a:r>
+              <a:rPr lang="en-US" sz="800" spc="-1" dirty="0">
+                <a:solidFill>
+                  <a:srgbClr val="000000"/>
+                </a:solidFill>
+                <a:latin typeface="Arial"/>
+              </a:rPr>
+              <a:t>FW HAL</a:t>
+            </a:r>
+            <a:endParaRPr lang="en-IN" sz="800" spc="-1" dirty="0">
+              <a:solidFill>
+                <a:srgbClr val="000000"/>
+              </a:solidFill>
+              <a:latin typeface="Arial"/>
+            </a:endParaRPr>
+          </a:p>
+        </p:txBody>
+      </p:sp>
+      <p:sp>
+        <p:nvSpPr>
+          <p:cNvPr id="65" name="CustomShape 4">
+            <a:extLst>
+              <a:ext uri="{FF2B5EF4-FFF2-40B4-BE49-F238E27FC236}">
+                <a16:creationId xmlns:a16="http://schemas.microsoft.com/office/drawing/2014/main" id="{FFADBA20-B845-4B87-A060-0D567C5D7B73}"/>
+              </a:ext>
+            </a:extLst>
+          </p:cNvPr>
+          <p:cNvSpPr/>
+          <p:nvPr/>
+        </p:nvSpPr>
+        <p:spPr>
+          <a:xfrm>
+            <a:off x="2975706" y="2494076"/>
+            <a:ext cx="476185" cy="314308"/>
+          </a:xfrm>
+          <a:prstGeom prst="rect">
+            <a:avLst/>
+          </a:prstGeom>
+          <a:solidFill>
+            <a:srgbClr val="92D050"/>
+          </a:solidFill>
+          <a:ln>
+            <a:noFill/>
+          </a:ln>
+          <a:effectLst>
+            <a:outerShdw blurRad="50760" dist="37674" dir="2700000" algn="tl" rotWithShape="0">
+              <a:srgbClr val="000000">
+                <a:alpha val="40000"/>
+              </a:srgbClr>
+            </a:outerShdw>
+          </a:effectLst>
+        </p:spPr>
+        <p:style>
+          <a:lnRef idx="2">
+            <a:schemeClr val="accent1">
+              <a:shade val="50000"/>
+            </a:schemeClr>
+          </a:lnRef>
+          <a:fillRef idx="1">
+            <a:schemeClr val="accent1"/>
+          </a:fillRef>
+          <a:effectRef idx="0">
+            <a:schemeClr val="accent1"/>
+          </a:effectRef>
+          <a:fontRef idx="minor"/>
+        </p:style>
+        <p:txBody>
+          <a:bodyPr lIns="56250" tIns="28125" rIns="56250" bIns="28125" anchor="ctr">
+            <a:noAutofit/>
+          </a:bodyPr>
+          <a:lstStyle/>
+          <a:p>
+            <a:pPr algn="ctr"/>
+            <a:r>
+              <a:rPr lang="en-US" sz="800" spc="-1" dirty="0">
+                <a:latin typeface="Arial"/>
+              </a:rPr>
+              <a:t>ICSS EMAC</a:t>
+            </a:r>
+            <a:endParaRPr lang="en-IN" sz="800" spc="-1" dirty="0">
+              <a:latin typeface="Arial"/>
+            </a:endParaRPr>
+          </a:p>
+        </p:txBody>
+      </p:sp>
+      <p:sp>
+        <p:nvSpPr>
+          <p:cNvPr id="66" name="CustomShape 15">
+            <a:extLst>
+              <a:ext uri="{FF2B5EF4-FFF2-40B4-BE49-F238E27FC236}">
+                <a16:creationId xmlns:a16="http://schemas.microsoft.com/office/drawing/2014/main" id="{30D4B83C-0642-40F3-B58E-D7629B644E49}"/>
+              </a:ext>
+            </a:extLst>
+          </p:cNvPr>
+          <p:cNvSpPr/>
+          <p:nvPr/>
+        </p:nvSpPr>
+        <p:spPr>
+          <a:xfrm>
+            <a:off x="2469415" y="2494076"/>
+            <a:ext cx="473238" cy="330895"/>
           </a:xfrm>
           <a:prstGeom prst="rect">
             <a:avLst/>

</xml_diff>

<commit_message>
am263px: docs: add QuickConnect in features not tested/supported
- add QuickConnect in features not tested/supported
- this is due to the delay of 200ms programmed in the app after PHY reset
- update the block diagram PPT to match the current SDK status
- minor formatting correction in am263x release notes

Fixes: PINDSW-8335

Signed-off-by: Archit Dev <a-dev@ti.com>
</commit_message>
<xml_diff>
--- a/docs_src/docs/api_guide/images/images.pptx
+++ b/docs_src/docs/api_guide/images/images.pptx
@@ -5,14 +5,13 @@
     <p:sldMasterId id="2147483648" r:id="rId1"/>
   </p:sldMasterIdLst>
   <p:notesMasterIdLst>
-    <p:notesMasterId r:id="rId7"/>
+    <p:notesMasterId r:id="rId6"/>
   </p:notesMasterIdLst>
   <p:sldIdLst>
     <p:sldId id="284" r:id="rId2"/>
     <p:sldId id="285" r:id="rId3"/>
     <p:sldId id="287" r:id="rId4"/>
-    <p:sldId id="288" r:id="rId5"/>
-    <p:sldId id="286" r:id="rId6"/>
+    <p:sldId id="286" r:id="rId5"/>
   </p:sldIdLst>
   <p:sldSz cx="9144000" cy="5143500" type="screen16x9"/>
   <p:notesSz cx="9296400" cy="14770100"/>
@@ -256,7 +255,7 @@
           <a:p>
             <a:fld id="{4ADF24D4-082E-4F97-B9C4-E0764843ED08}" type="datetimeFigureOut">
               <a:rPr lang="en-US" smtClean="0"/>
-              <a:t>12/17/2024</a:t>
+              <a:t>12/20/2024</a:t>
             </a:fld>
             <a:endParaRPr lang="en-US"/>
           </a:p>
@@ -9615,7 +9614,7 @@
           <a:p>
             <a:r>
               <a:rPr lang="en-US" sz="2400" dirty="0"/>
-              <a:t>Industrial Communications SDK AM263Px </a:t>
+              <a:t>Industrial Communications SDK AM263Px / AM261x </a:t>
             </a:r>
             <a:r>
               <a:rPr lang="en-US" sz="2400" dirty="0">
@@ -12173,2463 +12172,6 @@
 </file>
 
 <file path=ppt/slides/slide4.xml><?xml version="1.0" encoding="utf-8"?>
-<p:sld xmlns:a="http://schemas.openxmlformats.org/drawingml/2006/main" xmlns:r="http://schemas.openxmlformats.org/officeDocument/2006/relationships" xmlns:p="http://schemas.openxmlformats.org/presentationml/2006/main">
-  <p:cSld>
-    <p:spTree>
-      <p:nvGrpSpPr>
-        <p:cNvPr id="1" name=""/>
-        <p:cNvGrpSpPr/>
-        <p:nvPr/>
-      </p:nvGrpSpPr>
-      <p:grpSpPr>
-        <a:xfrm>
-          <a:off x="0" y="0"/>
-          <a:ext cx="0" cy="0"/>
-          <a:chOff x="0" y="0"/>
-          <a:chExt cx="0" cy="0"/>
-        </a:xfrm>
-      </p:grpSpPr>
-      <p:sp>
-        <p:nvSpPr>
-          <p:cNvPr id="2" name="Title 1">
-            <a:extLst>
-              <a:ext uri="{FF2B5EF4-FFF2-40B4-BE49-F238E27FC236}">
-                <a16:creationId xmlns:a16="http://schemas.microsoft.com/office/drawing/2014/main" id="{2725729B-986F-4361-8441-2202045AB807}"/>
-              </a:ext>
-            </a:extLst>
-          </p:cNvPr>
-          <p:cNvSpPr>
-            <a:spLocks noGrp="1"/>
-          </p:cNvSpPr>
-          <p:nvPr>
-            <p:ph type="title"/>
-          </p:nvPr>
-        </p:nvSpPr>
-        <p:spPr>
-          <a:xfrm>
-            <a:off x="231775" y="107163"/>
-            <a:ext cx="8458200" cy="610791"/>
-          </a:xfrm>
-        </p:spPr>
-        <p:txBody>
-          <a:bodyPr/>
-          <a:lstStyle/>
-          <a:p>
-            <a:r>
-              <a:rPr lang="en-US" sz="2400" dirty="0"/>
-              <a:t>Industrial Communications SDK AM261x </a:t>
-            </a:r>
-            <a:r>
-              <a:rPr lang="en-US" sz="2400" dirty="0">
-                <a:solidFill>
-                  <a:schemeClr val="tx1"/>
-                </a:solidFill>
-              </a:rPr>
-              <a:t>| Component Mapping</a:t>
-            </a:r>
-          </a:p>
-        </p:txBody>
-      </p:sp>
-      <p:sp>
-        <p:nvSpPr>
-          <p:cNvPr id="31" name="CustomShape 1">
-            <a:extLst>
-              <a:ext uri="{FF2B5EF4-FFF2-40B4-BE49-F238E27FC236}">
-                <a16:creationId xmlns:a16="http://schemas.microsoft.com/office/drawing/2014/main" id="{3D6B1C82-A4A8-46FB-83CF-8A3710C85B3C}"/>
-              </a:ext>
-            </a:extLst>
-          </p:cNvPr>
-          <p:cNvSpPr/>
-          <p:nvPr/>
-        </p:nvSpPr>
-        <p:spPr>
-          <a:xfrm>
-            <a:off x="1006780" y="2969553"/>
-            <a:ext cx="4476710" cy="666000"/>
-          </a:xfrm>
-          <a:prstGeom prst="rect">
-            <a:avLst/>
-          </a:prstGeom>
-          <a:noFill/>
-          <a:ln>
-            <a:solidFill>
-              <a:srgbClr val="000000"/>
-            </a:solidFill>
-            <a:round/>
-          </a:ln>
-        </p:spPr>
-        <p:style>
-          <a:lnRef idx="2">
-            <a:schemeClr val="accent1">
-              <a:shade val="50000"/>
-            </a:schemeClr>
-          </a:lnRef>
-          <a:fillRef idx="1">
-            <a:schemeClr val="accent1"/>
-          </a:fillRef>
-          <a:effectRef idx="0">
-            <a:schemeClr val="accent1"/>
-          </a:effectRef>
-          <a:fontRef idx="minor"/>
-        </p:style>
-        <p:txBody>
-          <a:bodyPr lIns="56250" tIns="28125" rIns="56250" bIns="28125" anchor="ctr">
-            <a:noAutofit/>
-          </a:bodyPr>
-          <a:lstStyle/>
-          <a:p>
-            <a:pPr>
-              <a:lnSpc>
-                <a:spcPct val="100000"/>
-              </a:lnSpc>
-              <a:buNone/>
-            </a:pPr>
-            <a:r>
-              <a:rPr lang="en-US" sz="1125" spc="-1" dirty="0">
-                <a:solidFill>
-                  <a:srgbClr val="000000"/>
-                </a:solidFill>
-                <a:latin typeface="Arial"/>
-                <a:ea typeface="DejaVu Sans"/>
-              </a:rPr>
-              <a:t>OS Kernel</a:t>
-            </a:r>
-            <a:endParaRPr lang="en-IN" sz="1125" spc="-1" dirty="0">
-              <a:latin typeface="Arial"/>
-            </a:endParaRPr>
-          </a:p>
-        </p:txBody>
-      </p:sp>
-      <p:sp>
-        <p:nvSpPr>
-          <p:cNvPr id="32" name="CustomShape 3">
-            <a:extLst>
-              <a:ext uri="{FF2B5EF4-FFF2-40B4-BE49-F238E27FC236}">
-                <a16:creationId xmlns:a16="http://schemas.microsoft.com/office/drawing/2014/main" id="{027E4027-03E2-4A1B-B844-0402A94E199E}"/>
-              </a:ext>
-            </a:extLst>
-          </p:cNvPr>
-          <p:cNvSpPr/>
-          <p:nvPr/>
-        </p:nvSpPr>
-        <p:spPr>
-          <a:xfrm>
-            <a:off x="3147237" y="3017253"/>
-            <a:ext cx="2231264" cy="237375"/>
-          </a:xfrm>
-          <a:prstGeom prst="rect">
-            <a:avLst/>
-          </a:prstGeom>
-          <a:solidFill>
-            <a:schemeClr val="bg2"/>
-          </a:solidFill>
-          <a:ln>
-            <a:noFill/>
-          </a:ln>
-          <a:effectLst>
-            <a:outerShdw blurRad="50760" dist="37674" dir="2700000" algn="tl" rotWithShape="0">
-              <a:srgbClr val="000000">
-                <a:alpha val="40000"/>
-              </a:srgbClr>
-            </a:outerShdw>
-          </a:effectLst>
-        </p:spPr>
-        <p:style>
-          <a:lnRef idx="2">
-            <a:schemeClr val="accent1">
-              <a:shade val="50000"/>
-            </a:schemeClr>
-          </a:lnRef>
-          <a:fillRef idx="1">
-            <a:schemeClr val="accent1"/>
-          </a:fillRef>
-          <a:effectRef idx="0">
-            <a:schemeClr val="accent1"/>
-          </a:effectRef>
-          <a:fontRef idx="minor"/>
-        </p:style>
-        <p:txBody>
-          <a:bodyPr lIns="56250" tIns="28125" rIns="56250" bIns="28125" anchor="ctr">
-            <a:noAutofit/>
-          </a:bodyPr>
-          <a:lstStyle/>
-          <a:p>
-            <a:pPr algn="ctr">
-              <a:lnSpc>
-                <a:spcPct val="100000"/>
-              </a:lnSpc>
-              <a:buNone/>
-            </a:pPr>
-            <a:r>
-              <a:rPr lang="en-US" sz="1000" spc="-1" dirty="0">
-                <a:solidFill>
-                  <a:srgbClr val="FFFFFF"/>
-                </a:solidFill>
-                <a:latin typeface="Arial"/>
-                <a:ea typeface="DejaVu Sans"/>
-              </a:rPr>
-              <a:t>Driver Porting Layer (DPL)</a:t>
-            </a:r>
-            <a:endParaRPr lang="en-IN" sz="1000" spc="-1" dirty="0">
-              <a:latin typeface="Arial"/>
-            </a:endParaRPr>
-          </a:p>
-        </p:txBody>
-      </p:sp>
-      <p:sp>
-        <p:nvSpPr>
-          <p:cNvPr id="33" name="CustomShape 5">
-            <a:extLst>
-              <a:ext uri="{FF2B5EF4-FFF2-40B4-BE49-F238E27FC236}">
-                <a16:creationId xmlns:a16="http://schemas.microsoft.com/office/drawing/2014/main" id="{C06CECDA-047B-456B-B3C4-FBDBB8AE720D}"/>
-              </a:ext>
-            </a:extLst>
-          </p:cNvPr>
-          <p:cNvSpPr/>
-          <p:nvPr/>
-        </p:nvSpPr>
-        <p:spPr>
-          <a:xfrm>
-            <a:off x="4346570" y="3303003"/>
-            <a:ext cx="1031932" cy="237375"/>
-          </a:xfrm>
-          <a:prstGeom prst="rect">
-            <a:avLst/>
-          </a:prstGeom>
-          <a:solidFill>
-            <a:schemeClr val="bg2"/>
-          </a:solidFill>
-          <a:ln>
-            <a:noFill/>
-          </a:ln>
-          <a:effectLst>
-            <a:outerShdw blurRad="50760" dist="37674" dir="2700000" algn="tl" rotWithShape="0">
-              <a:srgbClr val="000000">
-                <a:alpha val="40000"/>
-              </a:srgbClr>
-            </a:outerShdw>
-          </a:effectLst>
-        </p:spPr>
-        <p:style>
-          <a:lnRef idx="2">
-            <a:schemeClr val="accent1">
-              <a:shade val="50000"/>
-            </a:schemeClr>
-          </a:lnRef>
-          <a:fillRef idx="1">
-            <a:schemeClr val="accent1"/>
-          </a:fillRef>
-          <a:effectRef idx="0">
-            <a:schemeClr val="accent1"/>
-          </a:effectRef>
-          <a:fontRef idx="minor"/>
-        </p:style>
-        <p:txBody>
-          <a:bodyPr lIns="56250" tIns="28125" rIns="56250" bIns="28125" anchor="ctr">
-            <a:noAutofit/>
-          </a:bodyPr>
-          <a:lstStyle/>
-          <a:p>
-            <a:pPr algn="ctr">
-              <a:lnSpc>
-                <a:spcPct val="100000"/>
-              </a:lnSpc>
-              <a:buNone/>
-            </a:pPr>
-            <a:r>
-              <a:rPr lang="en-US" sz="1000" spc="-1" dirty="0">
-                <a:solidFill>
-                  <a:srgbClr val="FFFFFF"/>
-                </a:solidFill>
-                <a:latin typeface="Arial"/>
-                <a:ea typeface="DejaVu Sans"/>
-              </a:rPr>
-              <a:t>No RTOS</a:t>
-            </a:r>
-            <a:endParaRPr lang="en-IN" sz="1000" spc="-1" dirty="0">
-              <a:latin typeface="Arial"/>
-            </a:endParaRPr>
-          </a:p>
-        </p:txBody>
-      </p:sp>
-      <p:sp>
-        <p:nvSpPr>
-          <p:cNvPr id="34" name="CustomShape 6">
-            <a:extLst>
-              <a:ext uri="{FF2B5EF4-FFF2-40B4-BE49-F238E27FC236}">
-                <a16:creationId xmlns:a16="http://schemas.microsoft.com/office/drawing/2014/main" id="{FB3F104C-9E44-4EA3-A85B-FFB4FB3797C5}"/>
-              </a:ext>
-            </a:extLst>
-          </p:cNvPr>
-          <p:cNvSpPr/>
-          <p:nvPr/>
-        </p:nvSpPr>
-        <p:spPr>
-          <a:xfrm>
-            <a:off x="3147235" y="3303003"/>
-            <a:ext cx="1156677" cy="237375"/>
-          </a:xfrm>
-          <a:prstGeom prst="rect">
-            <a:avLst/>
-          </a:prstGeom>
-          <a:solidFill>
-            <a:schemeClr val="bg2"/>
-          </a:solidFill>
-          <a:ln>
-            <a:noFill/>
-          </a:ln>
-          <a:effectLst>
-            <a:outerShdw blurRad="50760" dist="37674" dir="2700000" algn="tl" rotWithShape="0">
-              <a:srgbClr val="000000">
-                <a:alpha val="40000"/>
-              </a:srgbClr>
-            </a:outerShdw>
-          </a:effectLst>
-        </p:spPr>
-        <p:style>
-          <a:lnRef idx="2">
-            <a:schemeClr val="accent1">
-              <a:shade val="50000"/>
-            </a:schemeClr>
-          </a:lnRef>
-          <a:fillRef idx="1">
-            <a:schemeClr val="accent1"/>
-          </a:fillRef>
-          <a:effectRef idx="0">
-            <a:schemeClr val="accent1"/>
-          </a:effectRef>
-          <a:fontRef idx="minor"/>
-        </p:style>
-        <p:txBody>
-          <a:bodyPr lIns="56250" tIns="28125" rIns="56250" bIns="28125" anchor="ctr">
-            <a:noAutofit/>
-          </a:bodyPr>
-          <a:lstStyle/>
-          <a:p>
-            <a:pPr algn="ctr">
-              <a:lnSpc>
-                <a:spcPct val="100000"/>
-              </a:lnSpc>
-              <a:buNone/>
-            </a:pPr>
-            <a:r>
-              <a:rPr lang="en-US" sz="1000" spc="-1" dirty="0">
-                <a:solidFill>
-                  <a:srgbClr val="FFFFFF"/>
-                </a:solidFill>
-                <a:latin typeface="Arial"/>
-                <a:ea typeface="DejaVu Sans"/>
-              </a:rPr>
-              <a:t>FreeRTOS Kernel</a:t>
-            </a:r>
-            <a:endParaRPr lang="en-IN" sz="1000" spc="-1" dirty="0">
-              <a:latin typeface="Arial"/>
-            </a:endParaRPr>
-          </a:p>
-        </p:txBody>
-      </p:sp>
-      <p:sp>
-        <p:nvSpPr>
-          <p:cNvPr id="35" name="CustomShape 7">
-            <a:extLst>
-              <a:ext uri="{FF2B5EF4-FFF2-40B4-BE49-F238E27FC236}">
-                <a16:creationId xmlns:a16="http://schemas.microsoft.com/office/drawing/2014/main" id="{D3E305A7-44B8-4EEF-9AF0-AE2E14551172}"/>
-              </a:ext>
-            </a:extLst>
-          </p:cNvPr>
-          <p:cNvSpPr/>
-          <p:nvPr/>
-        </p:nvSpPr>
-        <p:spPr>
-          <a:xfrm>
-            <a:off x="1879621" y="3017253"/>
-            <a:ext cx="1156677" cy="523125"/>
-          </a:xfrm>
-          <a:prstGeom prst="rect">
-            <a:avLst/>
-          </a:prstGeom>
-          <a:solidFill>
-            <a:schemeClr val="bg2"/>
-          </a:solidFill>
-          <a:ln>
-            <a:noFill/>
-          </a:ln>
-          <a:effectLst>
-            <a:outerShdw blurRad="50760" dist="37674" dir="2700000" algn="tl" rotWithShape="0">
-              <a:srgbClr val="000000">
-                <a:alpha val="40000"/>
-              </a:srgbClr>
-            </a:outerShdw>
-          </a:effectLst>
-        </p:spPr>
-        <p:style>
-          <a:lnRef idx="2">
-            <a:schemeClr val="accent1">
-              <a:shade val="50000"/>
-            </a:schemeClr>
-          </a:lnRef>
-          <a:fillRef idx="1">
-            <a:schemeClr val="accent1"/>
-          </a:fillRef>
-          <a:effectRef idx="0">
-            <a:schemeClr val="accent1"/>
-          </a:effectRef>
-          <a:fontRef idx="minor"/>
-        </p:style>
-        <p:txBody>
-          <a:bodyPr lIns="56250" tIns="28125" rIns="56250" bIns="28125" anchor="ctr">
-            <a:noAutofit/>
-          </a:bodyPr>
-          <a:lstStyle/>
-          <a:p>
-            <a:pPr algn="ctr">
-              <a:lnSpc>
-                <a:spcPct val="100000"/>
-              </a:lnSpc>
-              <a:buNone/>
-            </a:pPr>
-            <a:r>
-              <a:rPr lang="en-US" sz="1000" spc="-1" dirty="0">
-                <a:solidFill>
-                  <a:srgbClr val="FFFFFF"/>
-                </a:solidFill>
-                <a:latin typeface="Arial"/>
-                <a:ea typeface="DejaVu Sans"/>
-              </a:rPr>
-              <a:t>FreeRTOS POSIX </a:t>
-            </a:r>
-            <a:endParaRPr lang="en-IN" sz="1000" spc="-1" dirty="0">
-              <a:latin typeface="Arial"/>
-            </a:endParaRPr>
-          </a:p>
-        </p:txBody>
-      </p:sp>
-      <p:sp>
-        <p:nvSpPr>
-          <p:cNvPr id="36" name="CustomShape 8">
-            <a:extLst>
-              <a:ext uri="{FF2B5EF4-FFF2-40B4-BE49-F238E27FC236}">
-                <a16:creationId xmlns:a16="http://schemas.microsoft.com/office/drawing/2014/main" id="{5771F356-8F59-4ED9-B640-ACF71CACBA11}"/>
-              </a:ext>
-            </a:extLst>
-          </p:cNvPr>
-          <p:cNvSpPr/>
-          <p:nvPr/>
-        </p:nvSpPr>
-        <p:spPr>
-          <a:xfrm>
-            <a:off x="3843857" y="1102037"/>
-            <a:ext cx="677087" cy="281025"/>
-          </a:xfrm>
-          <a:prstGeom prst="rect">
-            <a:avLst/>
-          </a:prstGeom>
-          <a:solidFill>
-            <a:srgbClr val="92D050"/>
-          </a:solidFill>
-          <a:ln>
-            <a:noFill/>
-          </a:ln>
-          <a:effectLst>
-            <a:outerShdw blurRad="50760" dist="37674" dir="2700000" algn="tl" rotWithShape="0">
-              <a:srgbClr val="000000">
-                <a:alpha val="40000"/>
-              </a:srgbClr>
-            </a:outerShdw>
-          </a:effectLst>
-        </p:spPr>
-        <p:style>
-          <a:lnRef idx="2">
-            <a:schemeClr val="accent1">
-              <a:shade val="50000"/>
-            </a:schemeClr>
-          </a:lnRef>
-          <a:fillRef idx="1">
-            <a:schemeClr val="accent1"/>
-          </a:fillRef>
-          <a:effectRef idx="0">
-            <a:schemeClr val="accent1"/>
-          </a:effectRef>
-          <a:fontRef idx="minor"/>
-        </p:style>
-        <p:txBody>
-          <a:bodyPr lIns="56250" tIns="28125" rIns="56250" bIns="28125" anchor="ctr">
-            <a:noAutofit/>
-          </a:bodyPr>
-          <a:lstStyle/>
-          <a:p>
-            <a:pPr algn="ctr"/>
-            <a:r>
-              <a:rPr lang="en-US" sz="800" spc="-1" dirty="0">
-                <a:solidFill>
-                  <a:srgbClr val="000000"/>
-                </a:solidFill>
-              </a:rPr>
-              <a:t>EtherNet/IP</a:t>
-            </a:r>
-            <a:endParaRPr lang="en-IN" sz="800" spc="-1" dirty="0">
-              <a:solidFill>
-                <a:srgbClr val="000000"/>
-              </a:solidFill>
-            </a:endParaRPr>
-          </a:p>
-        </p:txBody>
-      </p:sp>
-      <p:sp>
-        <p:nvSpPr>
-          <p:cNvPr id="37" name="CustomShape 12">
-            <a:extLst>
-              <a:ext uri="{FF2B5EF4-FFF2-40B4-BE49-F238E27FC236}">
-                <a16:creationId xmlns:a16="http://schemas.microsoft.com/office/drawing/2014/main" id="{A219AA00-FE7B-4F6D-8122-6DE2E8EF6C33}"/>
-              </a:ext>
-            </a:extLst>
-          </p:cNvPr>
-          <p:cNvSpPr/>
-          <p:nvPr/>
-        </p:nvSpPr>
-        <p:spPr>
-          <a:xfrm>
-            <a:off x="1017221" y="1634625"/>
-            <a:ext cx="4476709" cy="666000"/>
-          </a:xfrm>
-          <a:prstGeom prst="rect">
-            <a:avLst/>
-          </a:prstGeom>
-          <a:noFill/>
-          <a:ln>
-            <a:solidFill>
-              <a:srgbClr val="000000"/>
-            </a:solidFill>
-            <a:round/>
-          </a:ln>
-        </p:spPr>
-        <p:style>
-          <a:lnRef idx="2">
-            <a:schemeClr val="accent1">
-              <a:shade val="50000"/>
-            </a:schemeClr>
-          </a:lnRef>
-          <a:fillRef idx="1">
-            <a:schemeClr val="accent1"/>
-          </a:fillRef>
-          <a:effectRef idx="0">
-            <a:schemeClr val="accent1"/>
-          </a:effectRef>
-          <a:fontRef idx="minor"/>
-        </p:style>
-        <p:txBody>
-          <a:bodyPr lIns="56250" tIns="28125" rIns="56250" bIns="28125" anchor="ctr">
-            <a:noAutofit/>
-          </a:bodyPr>
-          <a:lstStyle/>
-          <a:p>
-            <a:pPr>
-              <a:lnSpc>
-                <a:spcPct val="100000"/>
-              </a:lnSpc>
-              <a:buNone/>
-            </a:pPr>
-            <a:r>
-              <a:rPr lang="en-US" sz="1125" spc="-1" dirty="0">
-                <a:solidFill>
-                  <a:srgbClr val="000000"/>
-                </a:solidFill>
-                <a:latin typeface="Arial"/>
-                <a:ea typeface="DejaVu Sans"/>
-              </a:rPr>
-              <a:t>Protocol stacks</a:t>
-            </a:r>
-            <a:endParaRPr lang="en-IN" sz="1125" spc="-1" dirty="0">
-              <a:latin typeface="Arial"/>
-            </a:endParaRPr>
-          </a:p>
-          <a:p>
-            <a:pPr>
-              <a:lnSpc>
-                <a:spcPct val="100000"/>
-              </a:lnSpc>
-              <a:buNone/>
-            </a:pPr>
-            <a:r>
-              <a:rPr lang="en-US" sz="1125" spc="-1" dirty="0">
-                <a:solidFill>
-                  <a:srgbClr val="000000"/>
-                </a:solidFill>
-                <a:latin typeface="Arial"/>
-                <a:ea typeface="DejaVu Sans"/>
-              </a:rPr>
-              <a:t>And Middleware</a:t>
-            </a:r>
-            <a:endParaRPr lang="en-IN" sz="1125" spc="-1" dirty="0">
-              <a:latin typeface="Arial"/>
-            </a:endParaRPr>
-          </a:p>
-        </p:txBody>
-      </p:sp>
-      <p:sp>
-        <p:nvSpPr>
-          <p:cNvPr id="38" name="CustomShape 16">
-            <a:extLst>
-              <a:ext uri="{FF2B5EF4-FFF2-40B4-BE49-F238E27FC236}">
-                <a16:creationId xmlns:a16="http://schemas.microsoft.com/office/drawing/2014/main" id="{F4019BED-F334-42E5-8B43-FCD77FA246F2}"/>
-              </a:ext>
-            </a:extLst>
-          </p:cNvPr>
-          <p:cNvSpPr/>
-          <p:nvPr/>
-        </p:nvSpPr>
-        <p:spPr>
-          <a:xfrm>
-            <a:off x="1017222" y="957319"/>
-            <a:ext cx="4476709" cy="612932"/>
-          </a:xfrm>
-          <a:prstGeom prst="rect">
-            <a:avLst/>
-          </a:prstGeom>
-          <a:noFill/>
-          <a:ln>
-            <a:solidFill>
-              <a:srgbClr val="000000"/>
-            </a:solidFill>
-            <a:round/>
-          </a:ln>
-        </p:spPr>
-        <p:style>
-          <a:lnRef idx="2">
-            <a:schemeClr val="accent1">
-              <a:shade val="50000"/>
-            </a:schemeClr>
-          </a:lnRef>
-          <a:fillRef idx="1">
-            <a:schemeClr val="accent1"/>
-          </a:fillRef>
-          <a:effectRef idx="0">
-            <a:schemeClr val="accent1"/>
-          </a:effectRef>
-          <a:fontRef idx="minor"/>
-        </p:style>
-        <p:txBody>
-          <a:bodyPr lIns="56250" tIns="28125" rIns="56250" bIns="28125" anchor="ctr">
-            <a:noAutofit/>
-          </a:bodyPr>
-          <a:lstStyle/>
-          <a:p>
-            <a:pPr>
-              <a:lnSpc>
-                <a:spcPct val="100000"/>
-              </a:lnSpc>
-              <a:buNone/>
-            </a:pPr>
-            <a:r>
-              <a:rPr lang="en-US" sz="1125" spc="-1" dirty="0">
-                <a:solidFill>
-                  <a:srgbClr val="000000"/>
-                </a:solidFill>
-                <a:latin typeface="Arial"/>
-                <a:ea typeface="DejaVu Sans"/>
-              </a:rPr>
-              <a:t>Examples</a:t>
-            </a:r>
-            <a:endParaRPr lang="en-IN" sz="1125" spc="-1" dirty="0">
-              <a:latin typeface="Arial"/>
-            </a:endParaRPr>
-          </a:p>
-          <a:p>
-            <a:pPr>
-              <a:lnSpc>
-                <a:spcPct val="100000"/>
-              </a:lnSpc>
-              <a:buNone/>
-            </a:pPr>
-            <a:r>
-              <a:rPr lang="en-US" sz="1125" spc="-1" dirty="0">
-                <a:solidFill>
-                  <a:srgbClr val="000000"/>
-                </a:solidFill>
-                <a:latin typeface="Arial"/>
-                <a:ea typeface="DejaVu Sans"/>
-              </a:rPr>
-              <a:t>And Demos</a:t>
-            </a:r>
-            <a:endParaRPr lang="en-IN" sz="1125" spc="-1" dirty="0">
-              <a:latin typeface="Arial"/>
-            </a:endParaRPr>
-          </a:p>
-        </p:txBody>
-      </p:sp>
-      <p:sp>
-        <p:nvSpPr>
-          <p:cNvPr id="39" name="CustomShape 17">
-            <a:extLst>
-              <a:ext uri="{FF2B5EF4-FFF2-40B4-BE49-F238E27FC236}">
-                <a16:creationId xmlns:a16="http://schemas.microsoft.com/office/drawing/2014/main" id="{1511E327-23CE-4F9A-8587-9F496EA3DEDF}"/>
-              </a:ext>
-            </a:extLst>
-          </p:cNvPr>
-          <p:cNvSpPr/>
-          <p:nvPr/>
-        </p:nvSpPr>
-        <p:spPr>
-          <a:xfrm>
-            <a:off x="6547987" y="957317"/>
-            <a:ext cx="1197900" cy="2678235"/>
-          </a:xfrm>
-          <a:prstGeom prst="rect">
-            <a:avLst/>
-          </a:prstGeom>
-          <a:noFill/>
-          <a:ln>
-            <a:solidFill>
-              <a:srgbClr val="000000"/>
-            </a:solidFill>
-            <a:round/>
-          </a:ln>
-        </p:spPr>
-        <p:style>
-          <a:lnRef idx="2">
-            <a:schemeClr val="accent1">
-              <a:shade val="50000"/>
-            </a:schemeClr>
-          </a:lnRef>
-          <a:fillRef idx="1">
-            <a:schemeClr val="accent1"/>
-          </a:fillRef>
-          <a:effectRef idx="0">
-            <a:schemeClr val="accent1"/>
-          </a:effectRef>
-          <a:fontRef idx="minor"/>
-        </p:style>
-        <p:txBody>
-          <a:bodyPr lIns="56250" tIns="28125" rIns="56250" bIns="28125" anchor="t">
-            <a:noAutofit/>
-          </a:bodyPr>
-          <a:lstStyle/>
-          <a:p>
-            <a:pPr algn="ctr">
-              <a:lnSpc>
-                <a:spcPct val="100000"/>
-              </a:lnSpc>
-              <a:buNone/>
-            </a:pPr>
-            <a:r>
-              <a:rPr lang="en-US" sz="1125" spc="-1" dirty="0">
-                <a:solidFill>
-                  <a:srgbClr val="000000"/>
-                </a:solidFill>
-                <a:latin typeface="Arial"/>
-                <a:ea typeface="DejaVu Sans"/>
-              </a:rPr>
-              <a:t>Tools</a:t>
-            </a:r>
-            <a:endParaRPr lang="en-IN" sz="1125" spc="-1" dirty="0">
-              <a:latin typeface="Arial"/>
-            </a:endParaRPr>
-          </a:p>
-        </p:txBody>
-      </p:sp>
-      <p:sp>
-        <p:nvSpPr>
-          <p:cNvPr id="40" name="CustomShape 18">
-            <a:extLst>
-              <a:ext uri="{FF2B5EF4-FFF2-40B4-BE49-F238E27FC236}">
-                <a16:creationId xmlns:a16="http://schemas.microsoft.com/office/drawing/2014/main" id="{A9462506-F6FC-46E0-BCEB-716C7238530E}"/>
-              </a:ext>
-            </a:extLst>
-          </p:cNvPr>
-          <p:cNvSpPr/>
-          <p:nvPr/>
-        </p:nvSpPr>
-        <p:spPr>
-          <a:xfrm>
-            <a:off x="6641362" y="2278749"/>
-            <a:ext cx="1001475" cy="289125"/>
-          </a:xfrm>
-          <a:prstGeom prst="rect">
-            <a:avLst/>
-          </a:prstGeom>
-          <a:solidFill>
-            <a:schemeClr val="bg2"/>
-          </a:solidFill>
-          <a:ln>
-            <a:noFill/>
-          </a:ln>
-          <a:effectLst>
-            <a:outerShdw blurRad="50760" dist="37674" dir="2700000" algn="tl" rotWithShape="0">
-              <a:srgbClr val="000000">
-                <a:alpha val="40000"/>
-              </a:srgbClr>
-            </a:outerShdw>
-          </a:effectLst>
-        </p:spPr>
-        <p:style>
-          <a:lnRef idx="2">
-            <a:schemeClr val="accent1">
-              <a:shade val="50000"/>
-            </a:schemeClr>
-          </a:lnRef>
-          <a:fillRef idx="1">
-            <a:schemeClr val="accent1"/>
-          </a:fillRef>
-          <a:effectRef idx="0">
-            <a:schemeClr val="accent1"/>
-          </a:effectRef>
-          <a:fontRef idx="minor"/>
-        </p:style>
-        <p:txBody>
-          <a:bodyPr lIns="56250" tIns="28125" rIns="56250" bIns="28125" anchor="ctr">
-            <a:noAutofit/>
-          </a:bodyPr>
-          <a:lstStyle/>
-          <a:p>
-            <a:pPr algn="ctr"/>
-            <a:r>
-              <a:rPr lang="en-US" sz="1000" spc="-1" dirty="0">
-                <a:solidFill>
-                  <a:srgbClr val="FFFFFF"/>
-                </a:solidFill>
-                <a:latin typeface="Arial"/>
-              </a:rPr>
-              <a:t>SysConfig</a:t>
-            </a:r>
-            <a:endParaRPr lang="en-IN" sz="1000" spc="-1" dirty="0">
-              <a:solidFill>
-                <a:srgbClr val="FFFFFF"/>
-              </a:solidFill>
-              <a:latin typeface="Arial"/>
-            </a:endParaRPr>
-          </a:p>
-        </p:txBody>
-      </p:sp>
-      <p:sp>
-        <p:nvSpPr>
-          <p:cNvPr id="41" name="CustomShape 19">
-            <a:extLst>
-              <a:ext uri="{FF2B5EF4-FFF2-40B4-BE49-F238E27FC236}">
-                <a16:creationId xmlns:a16="http://schemas.microsoft.com/office/drawing/2014/main" id="{D47B997A-BA1C-46EB-8777-D9A34E732F4B}"/>
-              </a:ext>
-            </a:extLst>
-          </p:cNvPr>
-          <p:cNvSpPr/>
-          <p:nvPr/>
-        </p:nvSpPr>
-        <p:spPr>
-          <a:xfrm>
-            <a:off x="6641362" y="3108179"/>
-            <a:ext cx="1001475" cy="453183"/>
-          </a:xfrm>
-          <a:prstGeom prst="rect">
-            <a:avLst/>
-          </a:prstGeom>
-          <a:solidFill>
-            <a:schemeClr val="bg2"/>
-          </a:solidFill>
-          <a:ln>
-            <a:noFill/>
-          </a:ln>
-          <a:effectLst>
-            <a:outerShdw blurRad="50760" dist="37674" dir="2700000" algn="tl" rotWithShape="0">
-              <a:srgbClr val="000000">
-                <a:alpha val="40000"/>
-              </a:srgbClr>
-            </a:outerShdw>
-          </a:effectLst>
-        </p:spPr>
-        <p:style>
-          <a:lnRef idx="2">
-            <a:schemeClr val="accent1">
-              <a:shade val="50000"/>
-            </a:schemeClr>
-          </a:lnRef>
-          <a:fillRef idx="1">
-            <a:schemeClr val="accent1"/>
-          </a:fillRef>
-          <a:effectRef idx="0">
-            <a:schemeClr val="accent1"/>
-          </a:effectRef>
-          <a:fontRef idx="minor"/>
-        </p:style>
-        <p:txBody>
-          <a:bodyPr lIns="56250" tIns="28125" rIns="56250" bIns="28125" anchor="ctr">
-            <a:noAutofit/>
-          </a:bodyPr>
-          <a:lstStyle/>
-          <a:p>
-            <a:pPr algn="ctr"/>
-            <a:r>
-              <a:rPr lang="en-US" sz="1000" spc="-1" dirty="0">
-                <a:solidFill>
-                  <a:srgbClr val="FFFFFF"/>
-                </a:solidFill>
-                <a:latin typeface="Arial"/>
-              </a:rPr>
-              <a:t>Code Composer Studio (CCS)</a:t>
-            </a:r>
-            <a:endParaRPr lang="en-IN" sz="1000" spc="-1" dirty="0">
-              <a:solidFill>
-                <a:srgbClr val="FFFFFF"/>
-              </a:solidFill>
-              <a:latin typeface="Arial"/>
-            </a:endParaRPr>
-          </a:p>
-        </p:txBody>
-      </p:sp>
-      <p:sp>
-        <p:nvSpPr>
-          <p:cNvPr id="42" name="CustomShape 20">
-            <a:extLst>
-              <a:ext uri="{FF2B5EF4-FFF2-40B4-BE49-F238E27FC236}">
-                <a16:creationId xmlns:a16="http://schemas.microsoft.com/office/drawing/2014/main" id="{5051E15F-09FC-489F-B7C5-942AFC04970C}"/>
-              </a:ext>
-            </a:extLst>
-          </p:cNvPr>
-          <p:cNvSpPr/>
-          <p:nvPr/>
-        </p:nvSpPr>
-        <p:spPr>
-          <a:xfrm>
-            <a:off x="6641362" y="2643617"/>
-            <a:ext cx="1001475" cy="388350"/>
-          </a:xfrm>
-          <a:prstGeom prst="rect">
-            <a:avLst/>
-          </a:prstGeom>
-          <a:solidFill>
-            <a:schemeClr val="bg2"/>
-          </a:solidFill>
-          <a:ln>
-            <a:noFill/>
-          </a:ln>
-          <a:effectLst>
-            <a:outerShdw blurRad="50760" dist="37674" dir="2700000" algn="tl" rotWithShape="0">
-              <a:srgbClr val="000000">
-                <a:alpha val="40000"/>
-              </a:srgbClr>
-            </a:outerShdw>
-          </a:effectLst>
-        </p:spPr>
-        <p:style>
-          <a:lnRef idx="2">
-            <a:schemeClr val="accent1">
-              <a:shade val="50000"/>
-            </a:schemeClr>
-          </a:lnRef>
-          <a:fillRef idx="1">
-            <a:schemeClr val="accent1"/>
-          </a:fillRef>
-          <a:effectRef idx="0">
-            <a:schemeClr val="accent1"/>
-          </a:effectRef>
-          <a:fontRef idx="minor"/>
-        </p:style>
-        <p:txBody>
-          <a:bodyPr lIns="56250" tIns="28125" rIns="56250" bIns="28125" anchor="ctr">
-            <a:noAutofit/>
-          </a:bodyPr>
-          <a:lstStyle/>
-          <a:p>
-            <a:pPr algn="ctr"/>
-            <a:r>
-              <a:rPr lang="en-US" sz="1000" spc="-1" dirty="0">
-                <a:solidFill>
-                  <a:srgbClr val="FFFFFF"/>
-                </a:solidFill>
-                <a:latin typeface="Arial"/>
-              </a:rPr>
-              <a:t>TI CLANG Compiler</a:t>
-            </a:r>
-            <a:endParaRPr lang="en-IN" sz="1000" spc="-1" dirty="0">
-              <a:solidFill>
-                <a:srgbClr val="FFFFFF"/>
-              </a:solidFill>
-              <a:latin typeface="Arial"/>
-            </a:endParaRPr>
-          </a:p>
-        </p:txBody>
-      </p:sp>
-      <p:sp>
-        <p:nvSpPr>
-          <p:cNvPr id="43" name="CustomShape 21">
-            <a:extLst>
-              <a:ext uri="{FF2B5EF4-FFF2-40B4-BE49-F238E27FC236}">
-                <a16:creationId xmlns:a16="http://schemas.microsoft.com/office/drawing/2014/main" id="{3F772836-0AFC-4E1B-916B-C8303874696D}"/>
-              </a:ext>
-            </a:extLst>
-          </p:cNvPr>
-          <p:cNvSpPr/>
-          <p:nvPr/>
-        </p:nvSpPr>
-        <p:spPr>
-          <a:xfrm>
-            <a:off x="6641362" y="1763223"/>
-            <a:ext cx="1001475" cy="436246"/>
-          </a:xfrm>
-          <a:prstGeom prst="rect">
-            <a:avLst/>
-          </a:prstGeom>
-          <a:solidFill>
-            <a:schemeClr val="bg2"/>
-          </a:solidFill>
-          <a:ln>
-            <a:noFill/>
-          </a:ln>
-          <a:effectLst>
-            <a:outerShdw blurRad="50760" dist="37674" dir="2700000" algn="tl" rotWithShape="0">
-              <a:srgbClr val="000000">
-                <a:alpha val="40000"/>
-              </a:srgbClr>
-            </a:outerShdw>
-          </a:effectLst>
-        </p:spPr>
-        <p:style>
-          <a:lnRef idx="2">
-            <a:schemeClr val="accent1">
-              <a:shade val="50000"/>
-            </a:schemeClr>
-          </a:lnRef>
-          <a:fillRef idx="1">
-            <a:schemeClr val="accent1"/>
-          </a:fillRef>
-          <a:effectRef idx="0">
-            <a:schemeClr val="accent1"/>
-          </a:effectRef>
-          <a:fontRef idx="minor"/>
-        </p:style>
-        <p:txBody>
-          <a:bodyPr lIns="56250" tIns="28125" rIns="56250" bIns="28125" anchor="ctr">
-            <a:noAutofit/>
-          </a:bodyPr>
-          <a:lstStyle/>
-          <a:p>
-            <a:pPr algn="ctr"/>
-            <a:r>
-              <a:rPr lang="en-US" sz="1000" spc="-1" dirty="0">
-                <a:solidFill>
-                  <a:srgbClr val="FFFFFF"/>
-                </a:solidFill>
-                <a:latin typeface="Arial"/>
-              </a:rPr>
-              <a:t>TI Resource Explorer (TIREX)</a:t>
-            </a:r>
-            <a:endParaRPr lang="en-IN" sz="1000" spc="-1" dirty="0">
-              <a:solidFill>
-                <a:srgbClr val="FFFFFF"/>
-              </a:solidFill>
-              <a:latin typeface="Arial"/>
-            </a:endParaRPr>
-          </a:p>
-        </p:txBody>
-      </p:sp>
-      <p:sp>
-        <p:nvSpPr>
-          <p:cNvPr id="44" name="CustomShape 22">
-            <a:extLst>
-              <a:ext uri="{FF2B5EF4-FFF2-40B4-BE49-F238E27FC236}">
-                <a16:creationId xmlns:a16="http://schemas.microsoft.com/office/drawing/2014/main" id="{C91DD5CB-1EC3-449D-A186-019058DBE8A7}"/>
-              </a:ext>
-            </a:extLst>
-          </p:cNvPr>
-          <p:cNvSpPr/>
-          <p:nvPr/>
-        </p:nvSpPr>
-        <p:spPr>
-          <a:xfrm>
-            <a:off x="1006778" y="3687978"/>
-            <a:ext cx="4476711" cy="335592"/>
-          </a:xfrm>
-          <a:prstGeom prst="rect">
-            <a:avLst/>
-          </a:prstGeom>
-          <a:solidFill>
-            <a:schemeClr val="tx1"/>
-          </a:solidFill>
-          <a:ln>
-            <a:noFill/>
-          </a:ln>
-        </p:spPr>
-        <p:style>
-          <a:lnRef idx="2">
-            <a:schemeClr val="accent1">
-              <a:shade val="50000"/>
-            </a:schemeClr>
-          </a:lnRef>
-          <a:fillRef idx="1">
-            <a:schemeClr val="accent1"/>
-          </a:fillRef>
-          <a:effectRef idx="0">
-            <a:schemeClr val="accent1"/>
-          </a:effectRef>
-          <a:fontRef idx="minor"/>
-        </p:style>
-        <p:txBody>
-          <a:bodyPr lIns="56250" tIns="28125" rIns="56250" bIns="28125" anchor="ctr">
-            <a:noAutofit/>
-          </a:bodyPr>
-          <a:lstStyle/>
-          <a:p>
-            <a:pPr algn="ctr">
-              <a:lnSpc>
-                <a:spcPct val="100000"/>
-              </a:lnSpc>
-              <a:buNone/>
-            </a:pPr>
-            <a:r>
-              <a:rPr lang="en-US" sz="1000" spc="-1" dirty="0">
-                <a:solidFill>
-                  <a:srgbClr val="FFFFFF"/>
-                </a:solidFill>
-                <a:latin typeface="Arial"/>
-                <a:ea typeface="DejaVu Sans"/>
-              </a:rPr>
-              <a:t>ARM R5F, ARM M4F + SOC peripherals + EVM peripherals</a:t>
-            </a:r>
-            <a:endParaRPr lang="en-IN" sz="1000" spc="-1" dirty="0">
-              <a:latin typeface="Arial"/>
-            </a:endParaRPr>
-          </a:p>
-        </p:txBody>
-      </p:sp>
-      <p:sp>
-        <p:nvSpPr>
-          <p:cNvPr id="45" name="CustomShape 23">
-            <a:extLst>
-              <a:ext uri="{FF2B5EF4-FFF2-40B4-BE49-F238E27FC236}">
-                <a16:creationId xmlns:a16="http://schemas.microsoft.com/office/drawing/2014/main" id="{55DAEA8B-06F1-4AE5-B0DC-AFBC796322D9}"/>
-              </a:ext>
-            </a:extLst>
-          </p:cNvPr>
-          <p:cNvSpPr/>
-          <p:nvPr/>
-        </p:nvSpPr>
-        <p:spPr>
-          <a:xfrm>
-            <a:off x="6547987" y="3695853"/>
-            <a:ext cx="1197900" cy="327717"/>
-          </a:xfrm>
-          <a:prstGeom prst="rect">
-            <a:avLst/>
-          </a:prstGeom>
-          <a:solidFill>
-            <a:schemeClr val="tx1"/>
-          </a:solidFill>
-          <a:ln>
-            <a:noFill/>
-          </a:ln>
-        </p:spPr>
-        <p:style>
-          <a:lnRef idx="2">
-            <a:schemeClr val="accent1">
-              <a:shade val="50000"/>
-            </a:schemeClr>
-          </a:lnRef>
-          <a:fillRef idx="1">
-            <a:schemeClr val="accent1"/>
-          </a:fillRef>
-          <a:effectRef idx="0">
-            <a:schemeClr val="accent1"/>
-          </a:effectRef>
-          <a:fontRef idx="minor"/>
-        </p:style>
-        <p:txBody>
-          <a:bodyPr lIns="56250" tIns="28125" rIns="56250" bIns="28125" anchor="ctr">
-            <a:noAutofit/>
-          </a:bodyPr>
-          <a:lstStyle/>
-          <a:p>
-            <a:pPr algn="ctr">
-              <a:lnSpc>
-                <a:spcPct val="100000"/>
-              </a:lnSpc>
-              <a:buNone/>
-            </a:pPr>
-            <a:r>
-              <a:rPr lang="en-US" sz="1000" spc="-1" dirty="0">
-                <a:solidFill>
-                  <a:srgbClr val="FFFFFF"/>
-                </a:solidFill>
-                <a:latin typeface="Arial"/>
-                <a:ea typeface="DejaVu Sans"/>
-              </a:rPr>
-              <a:t>X86 Host (Windows / Linux)</a:t>
-            </a:r>
-            <a:endParaRPr lang="en-IN" sz="1000" spc="-1" dirty="0">
-              <a:latin typeface="Arial"/>
-            </a:endParaRPr>
-          </a:p>
-        </p:txBody>
-      </p:sp>
-      <p:sp>
-        <p:nvSpPr>
-          <p:cNvPr id="46" name="CustomShape 24">
-            <a:extLst>
-              <a:ext uri="{FF2B5EF4-FFF2-40B4-BE49-F238E27FC236}">
-                <a16:creationId xmlns:a16="http://schemas.microsoft.com/office/drawing/2014/main" id="{55C52026-75DE-45DF-90B7-586F49DE32CA}"/>
-              </a:ext>
-            </a:extLst>
-          </p:cNvPr>
-          <p:cNvSpPr/>
-          <p:nvPr/>
-        </p:nvSpPr>
-        <p:spPr>
-          <a:xfrm>
-            <a:off x="2883561" y="1102037"/>
-            <a:ext cx="677087" cy="281025"/>
-          </a:xfrm>
-          <a:prstGeom prst="rect">
-            <a:avLst/>
-          </a:prstGeom>
-          <a:solidFill>
-            <a:srgbClr val="92D050"/>
-          </a:solidFill>
-          <a:ln>
-            <a:noFill/>
-          </a:ln>
-          <a:effectLst>
-            <a:outerShdw blurRad="50760" dist="37674" dir="2700000" algn="tl" rotWithShape="0">
-              <a:srgbClr val="000000">
-                <a:alpha val="40000"/>
-              </a:srgbClr>
-            </a:outerShdw>
-          </a:effectLst>
-        </p:spPr>
-        <p:style>
-          <a:lnRef idx="2">
-            <a:schemeClr val="accent1">
-              <a:shade val="50000"/>
-            </a:schemeClr>
-          </a:lnRef>
-          <a:fillRef idx="1">
-            <a:schemeClr val="accent1"/>
-          </a:fillRef>
-          <a:effectRef idx="0">
-            <a:schemeClr val="accent1"/>
-          </a:effectRef>
-          <a:fontRef idx="minor"/>
-        </p:style>
-        <p:txBody>
-          <a:bodyPr lIns="56250" tIns="28125" rIns="56250" bIns="28125" anchor="ctr">
-            <a:noAutofit/>
-          </a:bodyPr>
-          <a:lstStyle/>
-          <a:p>
-            <a:pPr algn="ctr"/>
-            <a:r>
-              <a:rPr lang="en-US" sz="800" spc="-1" dirty="0">
-                <a:solidFill>
-                  <a:srgbClr val="000000"/>
-                </a:solidFill>
-              </a:rPr>
-              <a:t>EtherCAT</a:t>
-            </a:r>
-            <a:endParaRPr lang="en-IN" sz="800" spc="-1" dirty="0">
-              <a:solidFill>
-                <a:srgbClr val="000000"/>
-              </a:solidFill>
-            </a:endParaRPr>
-          </a:p>
-        </p:txBody>
-      </p:sp>
-      <p:sp>
-        <p:nvSpPr>
-          <p:cNvPr id="48" name="CustomShape 25">
-            <a:extLst>
-              <a:ext uri="{FF2B5EF4-FFF2-40B4-BE49-F238E27FC236}">
-                <a16:creationId xmlns:a16="http://schemas.microsoft.com/office/drawing/2014/main" id="{E248963F-77E6-433E-B036-FC49F5A3FD4B}"/>
-              </a:ext>
-            </a:extLst>
-          </p:cNvPr>
-          <p:cNvSpPr/>
-          <p:nvPr/>
-        </p:nvSpPr>
-        <p:spPr>
-          <a:xfrm>
-            <a:off x="6639674" y="1143593"/>
-            <a:ext cx="1001475" cy="544190"/>
-          </a:xfrm>
-          <a:prstGeom prst="rect">
-            <a:avLst/>
-          </a:prstGeom>
-          <a:solidFill>
-            <a:schemeClr val="bg2"/>
-          </a:solidFill>
-          <a:ln>
-            <a:noFill/>
-          </a:ln>
-          <a:effectLst>
-            <a:outerShdw blurRad="50760" dist="37674" dir="2700000" algn="tl" rotWithShape="0">
-              <a:srgbClr val="000000">
-                <a:alpha val="40000"/>
-              </a:srgbClr>
-            </a:outerShdw>
-          </a:effectLst>
-        </p:spPr>
-        <p:style>
-          <a:lnRef idx="2">
-            <a:schemeClr val="accent1">
-              <a:shade val="50000"/>
-            </a:schemeClr>
-          </a:lnRef>
-          <a:fillRef idx="1">
-            <a:schemeClr val="accent1"/>
-          </a:fillRef>
-          <a:effectRef idx="0">
-            <a:schemeClr val="accent1"/>
-          </a:effectRef>
-          <a:fontRef idx="minor"/>
-        </p:style>
-        <p:txBody>
-          <a:bodyPr lIns="56250" tIns="28125" rIns="56250" bIns="28125" anchor="ctr">
-            <a:noAutofit/>
-          </a:bodyPr>
-          <a:lstStyle/>
-          <a:p>
-            <a:pPr algn="ctr"/>
-            <a:r>
-              <a:rPr lang="en-US" sz="1000" spc="-1" dirty="0">
-                <a:solidFill>
-                  <a:srgbClr val="FFFFFF"/>
-                </a:solidFill>
-                <a:latin typeface="Arial"/>
-              </a:rPr>
-              <a:t>SDK Tools (Flashing, Boot, …)</a:t>
-            </a:r>
-            <a:endParaRPr lang="en-IN" sz="1000" spc="-1" dirty="0">
-              <a:solidFill>
-                <a:srgbClr val="FFFFFF"/>
-              </a:solidFill>
-              <a:latin typeface="Arial"/>
-            </a:endParaRPr>
-          </a:p>
-        </p:txBody>
-      </p:sp>
-      <p:sp>
-        <p:nvSpPr>
-          <p:cNvPr id="49" name="CustomShape 26">
-            <a:extLst>
-              <a:ext uri="{FF2B5EF4-FFF2-40B4-BE49-F238E27FC236}">
-                <a16:creationId xmlns:a16="http://schemas.microsoft.com/office/drawing/2014/main" id="{629D229C-F311-4CA2-9B7E-12CB2356B321}"/>
-              </a:ext>
-            </a:extLst>
-          </p:cNvPr>
-          <p:cNvSpPr/>
-          <p:nvPr/>
-        </p:nvSpPr>
-        <p:spPr>
-          <a:xfrm>
-            <a:off x="2547947" y="1811128"/>
-            <a:ext cx="661489" cy="261225"/>
-          </a:xfrm>
-          <a:prstGeom prst="rect">
-            <a:avLst/>
-          </a:prstGeom>
-          <a:solidFill>
-            <a:schemeClr val="bg2"/>
-          </a:solidFill>
-          <a:ln>
-            <a:noFill/>
-          </a:ln>
-          <a:effectLst>
-            <a:outerShdw blurRad="50760" dist="37674" dir="2700000" algn="tl" rotWithShape="0">
-              <a:srgbClr val="000000">
-                <a:alpha val="40000"/>
-              </a:srgbClr>
-            </a:outerShdw>
-          </a:effectLst>
-        </p:spPr>
-        <p:style>
-          <a:lnRef idx="2">
-            <a:schemeClr val="accent1">
-              <a:shade val="50000"/>
-            </a:schemeClr>
-          </a:lnRef>
-          <a:fillRef idx="1">
-            <a:schemeClr val="accent1"/>
-          </a:fillRef>
-          <a:effectRef idx="0">
-            <a:schemeClr val="accent1"/>
-          </a:effectRef>
-          <a:fontRef idx="minor"/>
-        </p:style>
-        <p:txBody>
-          <a:bodyPr lIns="56250" tIns="28125" rIns="56250" bIns="28125" anchor="ctr">
-            <a:noAutofit/>
-          </a:bodyPr>
-          <a:lstStyle/>
-          <a:p>
-            <a:pPr algn="ctr"/>
-            <a:r>
-              <a:rPr lang="en-US" sz="800" spc="-1" dirty="0">
-                <a:solidFill>
-                  <a:srgbClr val="FFFFFF"/>
-                </a:solidFill>
-                <a:latin typeface="Arial"/>
-              </a:rPr>
-              <a:t>LwIP  (TCP/UDP)</a:t>
-            </a:r>
-            <a:endParaRPr lang="en-IN" sz="800" spc="-1" dirty="0">
-              <a:solidFill>
-                <a:srgbClr val="FFFFFF"/>
-              </a:solidFill>
-              <a:latin typeface="Arial"/>
-            </a:endParaRPr>
-          </a:p>
-        </p:txBody>
-      </p:sp>
-      <p:sp>
-        <p:nvSpPr>
-          <p:cNvPr id="50" name="CustomShape 13">
-            <a:extLst>
-              <a:ext uri="{FF2B5EF4-FFF2-40B4-BE49-F238E27FC236}">
-                <a16:creationId xmlns:a16="http://schemas.microsoft.com/office/drawing/2014/main" id="{6C27F276-C0B7-489A-8B0C-5961CFE488B8}"/>
-              </a:ext>
-            </a:extLst>
-          </p:cNvPr>
-          <p:cNvSpPr/>
-          <p:nvPr/>
-        </p:nvSpPr>
-        <p:spPr>
-          <a:xfrm>
-            <a:off x="3560648" y="1818880"/>
-            <a:ext cx="660291" cy="261225"/>
-          </a:xfrm>
-          <a:prstGeom prst="rect">
-            <a:avLst/>
-          </a:prstGeom>
-          <a:solidFill>
-            <a:srgbClr val="92D050"/>
-          </a:solidFill>
-          <a:ln>
-            <a:noFill/>
-          </a:ln>
-          <a:effectLst>
-            <a:outerShdw blurRad="50760" dist="37674" dir="2700000" algn="tl" rotWithShape="0">
-              <a:srgbClr val="000000">
-                <a:alpha val="40000"/>
-              </a:srgbClr>
-            </a:outerShdw>
-          </a:effectLst>
-        </p:spPr>
-        <p:style>
-          <a:lnRef idx="2">
-            <a:schemeClr val="accent1">
-              <a:shade val="50000"/>
-            </a:schemeClr>
-          </a:lnRef>
-          <a:fillRef idx="1">
-            <a:schemeClr val="accent1"/>
-          </a:fillRef>
-          <a:effectRef idx="0">
-            <a:schemeClr val="accent1"/>
-          </a:effectRef>
-          <a:fontRef idx="minor"/>
-        </p:style>
-        <p:txBody>
-          <a:bodyPr lIns="56250" tIns="28125" rIns="56250" bIns="28125" anchor="ctr">
-            <a:noAutofit/>
-          </a:bodyPr>
-          <a:lstStyle/>
-          <a:p>
-            <a:pPr algn="ctr"/>
-            <a:r>
-              <a:rPr lang="en-US" sz="800" spc="-1" dirty="0">
-                <a:solidFill>
-                  <a:srgbClr val="000000"/>
-                </a:solidFill>
-                <a:latin typeface="Arial"/>
-              </a:rPr>
-              <a:t>EtherCAT</a:t>
-            </a:r>
-            <a:endParaRPr lang="en-IN" sz="800" spc="-1" dirty="0">
-              <a:solidFill>
-                <a:srgbClr val="000000"/>
-              </a:solidFill>
-              <a:latin typeface="Arial"/>
-            </a:endParaRPr>
-          </a:p>
-        </p:txBody>
-      </p:sp>
-      <p:sp>
-        <p:nvSpPr>
-          <p:cNvPr id="51" name="CustomShape 13">
-            <a:extLst>
-              <a:ext uri="{FF2B5EF4-FFF2-40B4-BE49-F238E27FC236}">
-                <a16:creationId xmlns:a16="http://schemas.microsoft.com/office/drawing/2014/main" id="{03DED8CF-9054-4A87-8C3B-B92831F61CD3}"/>
-              </a:ext>
-            </a:extLst>
-          </p:cNvPr>
-          <p:cNvSpPr/>
-          <p:nvPr/>
-        </p:nvSpPr>
-        <p:spPr>
-          <a:xfrm>
-            <a:off x="4481228" y="1818880"/>
-            <a:ext cx="661490" cy="261225"/>
-          </a:xfrm>
-          <a:prstGeom prst="rect">
-            <a:avLst/>
-          </a:prstGeom>
-          <a:solidFill>
-            <a:srgbClr val="92D050"/>
-          </a:solidFill>
-          <a:ln>
-            <a:noFill/>
-          </a:ln>
-          <a:effectLst>
-            <a:outerShdw blurRad="50760" dist="37674" dir="2700000" algn="tl" rotWithShape="0">
-              <a:srgbClr val="000000">
-                <a:alpha val="40000"/>
-              </a:srgbClr>
-            </a:outerShdw>
-          </a:effectLst>
-        </p:spPr>
-        <p:style>
-          <a:lnRef idx="2">
-            <a:schemeClr val="accent1">
-              <a:shade val="50000"/>
-            </a:schemeClr>
-          </a:lnRef>
-          <a:fillRef idx="1">
-            <a:schemeClr val="accent1"/>
-          </a:fillRef>
-          <a:effectRef idx="0">
-            <a:schemeClr val="accent1"/>
-          </a:effectRef>
-          <a:fontRef idx="minor"/>
-        </p:style>
-        <p:txBody>
-          <a:bodyPr lIns="56250" tIns="28125" rIns="56250" bIns="28125" anchor="ctr">
-            <a:noAutofit/>
-          </a:bodyPr>
-          <a:lstStyle/>
-          <a:p>
-            <a:pPr algn="ctr"/>
-            <a:r>
-              <a:rPr lang="en-US" sz="800" spc="-1" dirty="0">
-                <a:solidFill>
-                  <a:srgbClr val="000000"/>
-                </a:solidFill>
-                <a:latin typeface="Arial"/>
-              </a:rPr>
-              <a:t>EtherNet/IP</a:t>
-            </a:r>
-            <a:endParaRPr lang="en-IN" sz="800" spc="-1" dirty="0">
-              <a:solidFill>
-                <a:srgbClr val="000000"/>
-              </a:solidFill>
-              <a:latin typeface="Arial"/>
-            </a:endParaRPr>
-          </a:p>
-        </p:txBody>
-      </p:sp>
-      <p:sp>
-        <p:nvSpPr>
-          <p:cNvPr id="56" name="CustomShape 7">
-            <a:extLst>
-              <a:ext uri="{FF2B5EF4-FFF2-40B4-BE49-F238E27FC236}">
-                <a16:creationId xmlns:a16="http://schemas.microsoft.com/office/drawing/2014/main" id="{7D96CA54-26AC-4E13-9AB6-285EF42E4A34}"/>
-              </a:ext>
-            </a:extLst>
-          </p:cNvPr>
-          <p:cNvSpPr/>
-          <p:nvPr/>
-        </p:nvSpPr>
-        <p:spPr>
-          <a:xfrm>
-            <a:off x="3340217" y="4165439"/>
-            <a:ext cx="1114010" cy="335592"/>
-          </a:xfrm>
-          <a:prstGeom prst="rect">
-            <a:avLst/>
-          </a:prstGeom>
-          <a:solidFill>
-            <a:schemeClr val="bg2"/>
-          </a:solidFill>
-          <a:ln>
-            <a:noFill/>
-          </a:ln>
-          <a:effectLst>
-            <a:outerShdw blurRad="50760" dist="37674" dir="2700000" algn="tl" rotWithShape="0">
-              <a:srgbClr val="000000">
-                <a:alpha val="40000"/>
-              </a:srgbClr>
-            </a:outerShdw>
-          </a:effectLst>
-        </p:spPr>
-        <p:style>
-          <a:lnRef idx="2">
-            <a:schemeClr val="accent1">
-              <a:shade val="50000"/>
-            </a:schemeClr>
-          </a:lnRef>
-          <a:fillRef idx="1">
-            <a:schemeClr val="accent1"/>
-          </a:fillRef>
-          <a:effectRef idx="0">
-            <a:schemeClr val="accent1"/>
-          </a:effectRef>
-          <a:fontRef idx="minor"/>
-        </p:style>
-        <p:txBody>
-          <a:bodyPr lIns="56250" tIns="28125" rIns="56250" bIns="28125" anchor="ctr">
-            <a:noAutofit/>
-          </a:bodyPr>
-          <a:lstStyle/>
-          <a:p>
-            <a:pPr algn="ctr">
-              <a:lnSpc>
-                <a:spcPct val="100000"/>
-              </a:lnSpc>
-              <a:buNone/>
-            </a:pPr>
-            <a:r>
-              <a:rPr lang="en-US" sz="1000" spc="-1" dirty="0">
-                <a:solidFill>
-                  <a:srgbClr val="FFFFFF"/>
-                </a:solidFill>
-                <a:latin typeface="Arial"/>
-                <a:ea typeface="DejaVu Sans"/>
-              </a:rPr>
-              <a:t>MCU + SDK </a:t>
-            </a:r>
-            <a:endParaRPr lang="en-IN" sz="1000" spc="-1" dirty="0">
-              <a:latin typeface="Arial"/>
-            </a:endParaRPr>
-          </a:p>
-        </p:txBody>
-      </p:sp>
-      <p:sp>
-        <p:nvSpPr>
-          <p:cNvPr id="57" name="CustomShape 15">
-            <a:extLst>
-              <a:ext uri="{FF2B5EF4-FFF2-40B4-BE49-F238E27FC236}">
-                <a16:creationId xmlns:a16="http://schemas.microsoft.com/office/drawing/2014/main" id="{DB8E2469-E5D1-4237-AED9-E58C24376B56}"/>
-              </a:ext>
-            </a:extLst>
-          </p:cNvPr>
-          <p:cNvSpPr/>
-          <p:nvPr/>
-        </p:nvSpPr>
-        <p:spPr>
-          <a:xfrm>
-            <a:off x="4618164" y="4165439"/>
-            <a:ext cx="1114010" cy="335592"/>
-          </a:xfrm>
-          <a:prstGeom prst="rect">
-            <a:avLst/>
-          </a:prstGeom>
-          <a:solidFill>
-            <a:srgbClr val="92D050"/>
-          </a:solidFill>
-          <a:ln>
-            <a:noFill/>
-          </a:ln>
-          <a:effectLst>
-            <a:outerShdw blurRad="50760" dist="37674" dir="2700000" algn="tl" rotWithShape="0">
-              <a:srgbClr val="000000">
-                <a:alpha val="40000"/>
-              </a:srgbClr>
-            </a:outerShdw>
-          </a:effectLst>
-        </p:spPr>
-        <p:style>
-          <a:lnRef idx="2">
-            <a:schemeClr val="accent1">
-              <a:shade val="50000"/>
-            </a:schemeClr>
-          </a:lnRef>
-          <a:fillRef idx="1">
-            <a:schemeClr val="accent1"/>
-          </a:fillRef>
-          <a:effectRef idx="0">
-            <a:schemeClr val="accent1"/>
-          </a:effectRef>
-          <a:fontRef idx="minor"/>
-        </p:style>
-        <p:txBody>
-          <a:bodyPr lIns="56250" tIns="28125" rIns="56250" bIns="28125" anchor="ctr">
-            <a:noAutofit/>
-          </a:bodyPr>
-          <a:lstStyle/>
-          <a:p>
-            <a:pPr algn="ctr"/>
-            <a:r>
-              <a:rPr lang="en-IN" sz="800" spc="-1" dirty="0">
-                <a:solidFill>
-                  <a:srgbClr val="000000"/>
-                </a:solidFill>
-                <a:latin typeface="Arial"/>
-              </a:rPr>
-              <a:t>Industrial Communications SDK</a:t>
-            </a:r>
-          </a:p>
-        </p:txBody>
-      </p:sp>
-      <p:sp>
-        <p:nvSpPr>
-          <p:cNvPr id="58" name="CustomShape 17">
-            <a:extLst>
-              <a:ext uri="{FF2B5EF4-FFF2-40B4-BE49-F238E27FC236}">
-                <a16:creationId xmlns:a16="http://schemas.microsoft.com/office/drawing/2014/main" id="{B9098FA2-9AB5-4668-BA21-339322BCAFAB}"/>
-              </a:ext>
-            </a:extLst>
-          </p:cNvPr>
-          <p:cNvSpPr/>
-          <p:nvPr/>
-        </p:nvSpPr>
-        <p:spPr>
-          <a:xfrm>
-            <a:off x="5579137" y="957319"/>
-            <a:ext cx="877730" cy="2678234"/>
-          </a:xfrm>
-          <a:prstGeom prst="rect">
-            <a:avLst/>
-          </a:prstGeom>
-          <a:noFill/>
-          <a:ln>
-            <a:solidFill>
-              <a:srgbClr val="000000"/>
-            </a:solidFill>
-            <a:round/>
-          </a:ln>
-        </p:spPr>
-        <p:style>
-          <a:lnRef idx="2">
-            <a:schemeClr val="accent1">
-              <a:shade val="50000"/>
-            </a:schemeClr>
-          </a:lnRef>
-          <a:fillRef idx="1">
-            <a:schemeClr val="accent1"/>
-          </a:fillRef>
-          <a:effectRef idx="0">
-            <a:schemeClr val="accent1"/>
-          </a:effectRef>
-          <a:fontRef idx="minor"/>
-        </p:style>
-        <p:txBody>
-          <a:bodyPr lIns="56250" tIns="28125" rIns="56250" bIns="28125" anchor="t">
-            <a:noAutofit/>
-          </a:bodyPr>
-          <a:lstStyle/>
-          <a:p>
-            <a:pPr algn="ctr">
-              <a:lnSpc>
-                <a:spcPct val="100000"/>
-              </a:lnSpc>
-              <a:buNone/>
-            </a:pPr>
-            <a:r>
-              <a:rPr lang="en-US" sz="1125" spc="-1" dirty="0">
-                <a:solidFill>
-                  <a:srgbClr val="000000"/>
-                </a:solidFill>
-                <a:latin typeface="Arial"/>
-              </a:rPr>
-              <a:t>Firmware</a:t>
-            </a:r>
-            <a:endParaRPr lang="en-IN" sz="1125" spc="-1" dirty="0">
-              <a:latin typeface="Arial"/>
-            </a:endParaRPr>
-          </a:p>
-        </p:txBody>
-      </p:sp>
-      <p:sp>
-        <p:nvSpPr>
-          <p:cNvPr id="59" name="CustomShape 23">
-            <a:extLst>
-              <a:ext uri="{FF2B5EF4-FFF2-40B4-BE49-F238E27FC236}">
-                <a16:creationId xmlns:a16="http://schemas.microsoft.com/office/drawing/2014/main" id="{0FBE8A6C-DF86-47CE-99BF-6B39BA3F2CDE}"/>
-              </a:ext>
-            </a:extLst>
-          </p:cNvPr>
-          <p:cNvSpPr/>
-          <p:nvPr/>
-        </p:nvSpPr>
-        <p:spPr>
-          <a:xfrm>
-            <a:off x="5579137" y="3695853"/>
-            <a:ext cx="877730" cy="327717"/>
-          </a:xfrm>
-          <a:prstGeom prst="rect">
-            <a:avLst/>
-          </a:prstGeom>
-          <a:solidFill>
-            <a:schemeClr val="tx1"/>
-          </a:solidFill>
-          <a:ln>
-            <a:noFill/>
-          </a:ln>
-        </p:spPr>
-        <p:style>
-          <a:lnRef idx="2">
-            <a:schemeClr val="accent1">
-              <a:shade val="50000"/>
-            </a:schemeClr>
-          </a:lnRef>
-          <a:fillRef idx="1">
-            <a:schemeClr val="accent1"/>
-          </a:fillRef>
-          <a:effectRef idx="0">
-            <a:schemeClr val="accent1"/>
-          </a:effectRef>
-          <a:fontRef idx="minor"/>
-        </p:style>
-        <p:txBody>
-          <a:bodyPr lIns="56250" tIns="28125" rIns="56250" bIns="28125" anchor="ctr">
-            <a:noAutofit/>
-          </a:bodyPr>
-          <a:lstStyle/>
-          <a:p>
-            <a:pPr algn="ctr">
-              <a:lnSpc>
-                <a:spcPct val="100000"/>
-              </a:lnSpc>
-              <a:buNone/>
-            </a:pPr>
-            <a:r>
-              <a:rPr lang="en-US" sz="1000" spc="-1" dirty="0">
-                <a:solidFill>
-                  <a:srgbClr val="FFFFFF"/>
-                </a:solidFill>
-                <a:latin typeface="Arial"/>
-                <a:ea typeface="DejaVu Sans"/>
-              </a:rPr>
-              <a:t>ICSS</a:t>
-            </a:r>
-            <a:endParaRPr lang="en-IN" sz="1000" spc="-1" dirty="0">
-              <a:latin typeface="Arial"/>
-            </a:endParaRPr>
-          </a:p>
-        </p:txBody>
-      </p:sp>
-      <p:sp>
-        <p:nvSpPr>
-          <p:cNvPr id="60" name="CustomShape 8">
-            <a:extLst>
-              <a:ext uri="{FF2B5EF4-FFF2-40B4-BE49-F238E27FC236}">
-                <a16:creationId xmlns:a16="http://schemas.microsoft.com/office/drawing/2014/main" id="{562E42BB-D1AF-4D67-AB42-32C53E10CC03}"/>
-              </a:ext>
-            </a:extLst>
-          </p:cNvPr>
-          <p:cNvSpPr/>
-          <p:nvPr/>
-        </p:nvSpPr>
-        <p:spPr>
-          <a:xfrm>
-            <a:off x="5669746" y="1803421"/>
-            <a:ext cx="696511" cy="281025"/>
-          </a:xfrm>
-          <a:prstGeom prst="rect">
-            <a:avLst/>
-          </a:prstGeom>
-          <a:solidFill>
-            <a:srgbClr val="92D050"/>
-          </a:solidFill>
-          <a:ln>
-            <a:noFill/>
-          </a:ln>
-          <a:effectLst>
-            <a:outerShdw blurRad="50760" dist="37674" dir="2700000" algn="tl" rotWithShape="0">
-              <a:srgbClr val="000000">
-                <a:alpha val="40000"/>
-              </a:srgbClr>
-            </a:outerShdw>
-          </a:effectLst>
-        </p:spPr>
-        <p:style>
-          <a:lnRef idx="2">
-            <a:schemeClr val="accent1">
-              <a:shade val="50000"/>
-            </a:schemeClr>
-          </a:lnRef>
-          <a:fillRef idx="1">
-            <a:schemeClr val="accent1"/>
-          </a:fillRef>
-          <a:effectRef idx="0">
-            <a:schemeClr val="accent1"/>
-          </a:effectRef>
-          <a:fontRef idx="minor"/>
-        </p:style>
-        <p:txBody>
-          <a:bodyPr lIns="56250" tIns="28125" rIns="56250" bIns="28125" anchor="ctr">
-            <a:noAutofit/>
-          </a:bodyPr>
-          <a:lstStyle/>
-          <a:p>
-            <a:pPr algn="ctr"/>
-            <a:r>
-              <a:rPr lang="en-US" sz="800" spc="-1" dirty="0">
-                <a:solidFill>
-                  <a:srgbClr val="000000"/>
-                </a:solidFill>
-                <a:latin typeface="Arial"/>
-              </a:rPr>
-              <a:t>EtherNet/IP</a:t>
-            </a:r>
-            <a:endParaRPr lang="en-IN" sz="800" spc="-1" dirty="0">
-              <a:solidFill>
-                <a:srgbClr val="000000"/>
-              </a:solidFill>
-              <a:latin typeface="Arial"/>
-            </a:endParaRPr>
-          </a:p>
-        </p:txBody>
-      </p:sp>
-      <p:sp>
-        <p:nvSpPr>
-          <p:cNvPr id="61" name="CustomShape 8">
-            <a:extLst>
-              <a:ext uri="{FF2B5EF4-FFF2-40B4-BE49-F238E27FC236}">
-                <a16:creationId xmlns:a16="http://schemas.microsoft.com/office/drawing/2014/main" id="{A8613434-FC6B-4320-9913-B9FBE0D18C1A}"/>
-              </a:ext>
-            </a:extLst>
-          </p:cNvPr>
-          <p:cNvSpPr/>
-          <p:nvPr/>
-        </p:nvSpPr>
-        <p:spPr>
-          <a:xfrm>
-            <a:off x="5678728" y="2485352"/>
-            <a:ext cx="696511" cy="281025"/>
-          </a:xfrm>
-          <a:prstGeom prst="rect">
-            <a:avLst/>
-          </a:prstGeom>
-          <a:solidFill>
-            <a:srgbClr val="92D050"/>
-          </a:solidFill>
-          <a:ln>
-            <a:noFill/>
-          </a:ln>
-          <a:effectLst>
-            <a:outerShdw blurRad="50760" dist="37674" dir="2700000" algn="tl" rotWithShape="0">
-              <a:srgbClr val="000000">
-                <a:alpha val="40000"/>
-              </a:srgbClr>
-            </a:outerShdw>
-          </a:effectLst>
-        </p:spPr>
-        <p:style>
-          <a:lnRef idx="2">
-            <a:schemeClr val="accent1">
-              <a:shade val="50000"/>
-            </a:schemeClr>
-          </a:lnRef>
-          <a:fillRef idx="1">
-            <a:schemeClr val="accent1"/>
-          </a:fillRef>
-          <a:effectRef idx="0">
-            <a:schemeClr val="accent1"/>
-          </a:effectRef>
-          <a:fontRef idx="minor"/>
-        </p:style>
-        <p:txBody>
-          <a:bodyPr lIns="56250" tIns="28125" rIns="56250" bIns="28125" anchor="ctr">
-            <a:noAutofit/>
-          </a:bodyPr>
-          <a:lstStyle/>
-          <a:p>
-            <a:pPr algn="ctr"/>
-            <a:r>
-              <a:rPr lang="en-US" sz="800" spc="-1" dirty="0">
-                <a:solidFill>
-                  <a:srgbClr val="000000"/>
-                </a:solidFill>
-                <a:latin typeface="Arial"/>
-              </a:rPr>
-              <a:t>EtherCAT</a:t>
-            </a:r>
-            <a:endParaRPr lang="en-IN" sz="800" spc="-1" dirty="0">
-              <a:solidFill>
-                <a:srgbClr val="000000"/>
-              </a:solidFill>
-              <a:latin typeface="Arial"/>
-            </a:endParaRPr>
-          </a:p>
-        </p:txBody>
-      </p:sp>
-      <p:sp>
-        <p:nvSpPr>
-          <p:cNvPr id="63" name="CustomShape 4">
-            <a:extLst>
-              <a:ext uri="{FF2B5EF4-FFF2-40B4-BE49-F238E27FC236}">
-                <a16:creationId xmlns:a16="http://schemas.microsoft.com/office/drawing/2014/main" id="{31575CFA-6CDA-4C5E-9CBA-7612DCC9D49F}"/>
-              </a:ext>
-            </a:extLst>
-          </p:cNvPr>
-          <p:cNvSpPr/>
-          <p:nvPr/>
-        </p:nvSpPr>
-        <p:spPr>
-          <a:xfrm>
-            <a:off x="2623370" y="2486461"/>
-            <a:ext cx="587485" cy="314308"/>
-          </a:xfrm>
-          <a:prstGeom prst="rect">
-            <a:avLst/>
-          </a:prstGeom>
-          <a:solidFill>
-            <a:schemeClr val="bg2"/>
-          </a:solidFill>
-          <a:ln>
-            <a:noFill/>
-          </a:ln>
-          <a:effectLst>
-            <a:outerShdw blurRad="50760" dist="37674" dir="2700000" algn="tl" rotWithShape="0">
-              <a:srgbClr val="000000">
-                <a:alpha val="40000"/>
-              </a:srgbClr>
-            </a:outerShdw>
-          </a:effectLst>
-        </p:spPr>
-        <p:style>
-          <a:lnRef idx="2">
-            <a:schemeClr val="accent1">
-              <a:shade val="50000"/>
-            </a:schemeClr>
-          </a:lnRef>
-          <a:fillRef idx="1">
-            <a:schemeClr val="accent1"/>
-          </a:fillRef>
-          <a:effectRef idx="0">
-            <a:schemeClr val="accent1"/>
-          </a:effectRef>
-          <a:fontRef idx="minor"/>
-        </p:style>
-        <p:txBody>
-          <a:bodyPr lIns="56250" tIns="28125" rIns="56250" bIns="28125" anchor="ctr">
-            <a:noAutofit/>
-          </a:bodyPr>
-          <a:lstStyle/>
-          <a:p>
-            <a:pPr algn="ctr"/>
-            <a:r>
-              <a:rPr lang="en-US" sz="800" spc="-1" dirty="0">
-                <a:solidFill>
-                  <a:srgbClr val="FFFFFF"/>
-                </a:solidFill>
-                <a:latin typeface="Arial"/>
-              </a:rPr>
-              <a:t>SOC Peripheral</a:t>
-            </a:r>
-            <a:endParaRPr lang="en-IN" sz="800" spc="-1" dirty="0">
-              <a:solidFill>
-                <a:srgbClr val="FFFFFF"/>
-              </a:solidFill>
-              <a:latin typeface="Arial"/>
-            </a:endParaRPr>
-          </a:p>
-        </p:txBody>
-      </p:sp>
-      <p:sp>
-        <p:nvSpPr>
-          <p:cNvPr id="64" name="CustomShape 14">
-            <a:extLst>
-              <a:ext uri="{FF2B5EF4-FFF2-40B4-BE49-F238E27FC236}">
-                <a16:creationId xmlns:a16="http://schemas.microsoft.com/office/drawing/2014/main" id="{8D6446DB-253F-44C7-AA64-956E4678C5A5}"/>
-              </a:ext>
-            </a:extLst>
-          </p:cNvPr>
-          <p:cNvSpPr/>
-          <p:nvPr/>
-        </p:nvSpPr>
-        <p:spPr>
-          <a:xfrm>
-            <a:off x="1017221" y="2354403"/>
-            <a:ext cx="4476710" cy="542925"/>
-          </a:xfrm>
-          <a:prstGeom prst="rect">
-            <a:avLst/>
-          </a:prstGeom>
-          <a:noFill/>
-          <a:ln>
-            <a:solidFill>
-              <a:srgbClr val="000000"/>
-            </a:solidFill>
-            <a:round/>
-          </a:ln>
-        </p:spPr>
-        <p:style>
-          <a:lnRef idx="2">
-            <a:schemeClr val="accent1">
-              <a:shade val="50000"/>
-            </a:schemeClr>
-          </a:lnRef>
-          <a:fillRef idx="1">
-            <a:schemeClr val="accent1"/>
-          </a:fillRef>
-          <a:effectRef idx="0">
-            <a:schemeClr val="accent1"/>
-          </a:effectRef>
-          <a:fontRef idx="minor"/>
-        </p:style>
-        <p:txBody>
-          <a:bodyPr lIns="56250" tIns="28125" rIns="56250" bIns="28125" anchor="ctr">
-            <a:noAutofit/>
-          </a:bodyPr>
-          <a:lstStyle/>
-          <a:p>
-            <a:pPr>
-              <a:lnSpc>
-                <a:spcPct val="100000"/>
-              </a:lnSpc>
-              <a:buNone/>
-            </a:pPr>
-            <a:r>
-              <a:rPr lang="en-US" sz="1125" spc="-1" dirty="0">
-                <a:solidFill>
-                  <a:srgbClr val="000000"/>
-                </a:solidFill>
-                <a:latin typeface="Arial"/>
-                <a:ea typeface="DejaVu Sans"/>
-              </a:rPr>
-              <a:t>Drivers </a:t>
-            </a:r>
-          </a:p>
-          <a:p>
-            <a:pPr>
-              <a:lnSpc>
-                <a:spcPct val="100000"/>
-              </a:lnSpc>
-              <a:buNone/>
-            </a:pPr>
-            <a:r>
-              <a:rPr lang="en-US" sz="1125" spc="-1" dirty="0">
-                <a:solidFill>
-                  <a:srgbClr val="000000"/>
-                </a:solidFill>
-                <a:latin typeface="Arial"/>
-                <a:ea typeface="DejaVu Sans"/>
-              </a:rPr>
-              <a:t>And</a:t>
-            </a:r>
-            <a:r>
-              <a:rPr lang="en-IN" sz="1125" spc="-1" dirty="0">
-                <a:latin typeface="Arial"/>
-              </a:rPr>
-              <a:t> </a:t>
-            </a:r>
-            <a:r>
-              <a:rPr lang="en-US" sz="1125" spc="-1" dirty="0">
-                <a:solidFill>
-                  <a:srgbClr val="000000"/>
-                </a:solidFill>
-                <a:latin typeface="Arial"/>
-                <a:ea typeface="DejaVu Sans"/>
-              </a:rPr>
-              <a:t>HAL</a:t>
-            </a:r>
-            <a:endParaRPr lang="en-IN" sz="1125" spc="-1" dirty="0">
-              <a:latin typeface="Arial"/>
-            </a:endParaRPr>
-          </a:p>
-        </p:txBody>
-      </p:sp>
-      <p:sp>
-        <p:nvSpPr>
-          <p:cNvPr id="65" name="CustomShape 15">
-            <a:extLst>
-              <a:ext uri="{FF2B5EF4-FFF2-40B4-BE49-F238E27FC236}">
-                <a16:creationId xmlns:a16="http://schemas.microsoft.com/office/drawing/2014/main" id="{4BBC5DB1-53F2-4D5E-A6F9-CB8C0331E3EB}"/>
-              </a:ext>
-            </a:extLst>
-          </p:cNvPr>
-          <p:cNvSpPr/>
-          <p:nvPr/>
-        </p:nvSpPr>
-        <p:spPr>
-          <a:xfrm>
-            <a:off x="1925449" y="2486847"/>
-            <a:ext cx="584480" cy="313537"/>
-          </a:xfrm>
-          <a:prstGeom prst="rect">
-            <a:avLst/>
-          </a:prstGeom>
-          <a:solidFill>
-            <a:schemeClr val="bg2"/>
-          </a:solidFill>
-          <a:ln>
-            <a:noFill/>
-          </a:ln>
-          <a:effectLst>
-            <a:outerShdw blurRad="50760" dist="37674" dir="2700000" algn="tl" rotWithShape="0">
-              <a:srgbClr val="000000">
-                <a:alpha val="40000"/>
-              </a:srgbClr>
-            </a:outerShdw>
-          </a:effectLst>
-        </p:spPr>
-        <p:style>
-          <a:lnRef idx="2">
-            <a:schemeClr val="accent1">
-              <a:shade val="50000"/>
-            </a:schemeClr>
-          </a:lnRef>
-          <a:fillRef idx="1">
-            <a:schemeClr val="accent1"/>
-          </a:fillRef>
-          <a:effectRef idx="0">
-            <a:schemeClr val="accent1"/>
-          </a:effectRef>
-          <a:fontRef idx="minor"/>
-        </p:style>
-        <p:txBody>
-          <a:bodyPr lIns="56250" tIns="28125" rIns="56250" bIns="28125" anchor="ctr">
-            <a:noAutofit/>
-          </a:bodyPr>
-          <a:lstStyle/>
-          <a:p>
-            <a:pPr algn="ctr"/>
-            <a:r>
-              <a:rPr lang="en-US" sz="800" spc="-1" dirty="0">
-                <a:solidFill>
-                  <a:srgbClr val="FFFFFF"/>
-                </a:solidFill>
-                <a:latin typeface="Arial"/>
-              </a:rPr>
-              <a:t>Board Peripheral</a:t>
-            </a:r>
-            <a:endParaRPr lang="en-IN" sz="800" spc="-1" dirty="0">
-              <a:solidFill>
-                <a:srgbClr val="FFFFFF"/>
-              </a:solidFill>
-              <a:latin typeface="Arial"/>
-            </a:endParaRPr>
-          </a:p>
-        </p:txBody>
-      </p:sp>
-      <p:sp>
-        <p:nvSpPr>
-          <p:cNvPr id="66" name="CustomShape 15">
-            <a:extLst>
-              <a:ext uri="{FF2B5EF4-FFF2-40B4-BE49-F238E27FC236}">
-                <a16:creationId xmlns:a16="http://schemas.microsoft.com/office/drawing/2014/main" id="{A4DA8C57-A76D-4852-9025-EE496583FEBA}"/>
-              </a:ext>
-            </a:extLst>
-          </p:cNvPr>
-          <p:cNvSpPr/>
-          <p:nvPr/>
-        </p:nvSpPr>
-        <p:spPr>
-          <a:xfrm>
-            <a:off x="4025222" y="2494011"/>
-            <a:ext cx="579226" cy="310587"/>
-          </a:xfrm>
-          <a:prstGeom prst="rect">
-            <a:avLst/>
-          </a:prstGeom>
-          <a:solidFill>
-            <a:srgbClr val="92D050"/>
-          </a:solidFill>
-          <a:ln>
-            <a:noFill/>
-          </a:ln>
-          <a:effectLst>
-            <a:outerShdw blurRad="50760" dist="37674" dir="2700000" algn="tl" rotWithShape="0">
-              <a:srgbClr val="000000">
-                <a:alpha val="40000"/>
-              </a:srgbClr>
-            </a:outerShdw>
-          </a:effectLst>
-        </p:spPr>
-        <p:style>
-          <a:lnRef idx="2">
-            <a:schemeClr val="accent1">
-              <a:shade val="50000"/>
-            </a:schemeClr>
-          </a:lnRef>
-          <a:fillRef idx="1">
-            <a:schemeClr val="accent1"/>
-          </a:fillRef>
-          <a:effectRef idx="0">
-            <a:schemeClr val="accent1"/>
-          </a:effectRef>
-          <a:fontRef idx="minor"/>
-        </p:style>
-        <p:txBody>
-          <a:bodyPr lIns="56250" tIns="28125" rIns="56250" bIns="28125" anchor="ctr">
-            <a:noAutofit/>
-          </a:bodyPr>
-          <a:lstStyle/>
-          <a:p>
-            <a:pPr algn="ctr"/>
-            <a:r>
-              <a:rPr lang="en-US" sz="800" spc="-1" dirty="0">
-                <a:solidFill>
-                  <a:srgbClr val="000000"/>
-                </a:solidFill>
-                <a:latin typeface="Arial"/>
-              </a:rPr>
-              <a:t>EtherCAT FW HAL</a:t>
-            </a:r>
-            <a:endParaRPr lang="en-IN" sz="800" spc="-1" dirty="0">
-              <a:solidFill>
-                <a:srgbClr val="000000"/>
-              </a:solidFill>
-              <a:latin typeface="Arial"/>
-            </a:endParaRPr>
-          </a:p>
-        </p:txBody>
-      </p:sp>
-      <p:sp>
-        <p:nvSpPr>
-          <p:cNvPr id="67" name="CustomShape 15">
-            <a:extLst>
-              <a:ext uri="{FF2B5EF4-FFF2-40B4-BE49-F238E27FC236}">
-                <a16:creationId xmlns:a16="http://schemas.microsoft.com/office/drawing/2014/main" id="{BA954033-0EAF-42D4-806D-375DFBEBB11D}"/>
-              </a:ext>
-            </a:extLst>
-          </p:cNvPr>
-          <p:cNvSpPr/>
-          <p:nvPr/>
-        </p:nvSpPr>
-        <p:spPr>
-          <a:xfrm>
-            <a:off x="4717889" y="2486075"/>
-            <a:ext cx="706460" cy="315079"/>
-          </a:xfrm>
-          <a:prstGeom prst="rect">
-            <a:avLst/>
-          </a:prstGeom>
-          <a:solidFill>
-            <a:srgbClr val="92D050"/>
-          </a:solidFill>
-          <a:ln>
-            <a:noFill/>
-          </a:ln>
-          <a:effectLst>
-            <a:outerShdw blurRad="50760" dist="37674" dir="2700000" algn="tl" rotWithShape="0">
-              <a:srgbClr val="000000">
-                <a:alpha val="40000"/>
-              </a:srgbClr>
-            </a:outerShdw>
-          </a:effectLst>
-        </p:spPr>
-        <p:style>
-          <a:lnRef idx="2">
-            <a:schemeClr val="accent1">
-              <a:shade val="50000"/>
-            </a:schemeClr>
-          </a:lnRef>
-          <a:fillRef idx="1">
-            <a:schemeClr val="accent1"/>
-          </a:fillRef>
-          <a:effectRef idx="0">
-            <a:schemeClr val="accent1"/>
-          </a:effectRef>
-          <a:fontRef idx="minor"/>
-        </p:style>
-        <p:txBody>
-          <a:bodyPr lIns="56250" tIns="28125" rIns="56250" bIns="28125" anchor="ctr">
-            <a:noAutofit/>
-          </a:bodyPr>
-          <a:lstStyle/>
-          <a:p>
-            <a:pPr algn="ctr"/>
-            <a:r>
-              <a:rPr lang="en-US" sz="800" spc="-1" dirty="0">
-                <a:solidFill>
-                  <a:srgbClr val="000000"/>
-                </a:solidFill>
-                <a:latin typeface="Arial"/>
-              </a:rPr>
-              <a:t>EtherNet/IP FW HAL</a:t>
-            </a:r>
-            <a:endParaRPr lang="en-IN" sz="800" spc="-1" dirty="0">
-              <a:solidFill>
-                <a:srgbClr val="000000"/>
-              </a:solidFill>
-              <a:latin typeface="Arial"/>
-            </a:endParaRPr>
-          </a:p>
-        </p:txBody>
-      </p:sp>
-      <p:sp>
-        <p:nvSpPr>
-          <p:cNvPr id="68" name="CustomShape 4">
-            <a:extLst>
-              <a:ext uri="{FF2B5EF4-FFF2-40B4-BE49-F238E27FC236}">
-                <a16:creationId xmlns:a16="http://schemas.microsoft.com/office/drawing/2014/main" id="{D32585E2-BF01-48E3-9C7B-529384C18850}"/>
-              </a:ext>
-            </a:extLst>
-          </p:cNvPr>
-          <p:cNvSpPr/>
-          <p:nvPr/>
-        </p:nvSpPr>
-        <p:spPr>
-          <a:xfrm>
-            <a:off x="3324296" y="2486461"/>
-            <a:ext cx="587485" cy="314308"/>
-          </a:xfrm>
-          <a:prstGeom prst="rect">
-            <a:avLst/>
-          </a:prstGeom>
-          <a:solidFill>
-            <a:schemeClr val="bg2"/>
-          </a:solidFill>
-          <a:ln>
-            <a:noFill/>
-          </a:ln>
-          <a:effectLst>
-            <a:outerShdw blurRad="50760" dist="37674" dir="2700000" algn="tl" rotWithShape="0">
-              <a:srgbClr val="000000">
-                <a:alpha val="40000"/>
-              </a:srgbClr>
-            </a:outerShdw>
-          </a:effectLst>
-        </p:spPr>
-        <p:style>
-          <a:lnRef idx="2">
-            <a:schemeClr val="accent1">
-              <a:shade val="50000"/>
-            </a:schemeClr>
-          </a:lnRef>
-          <a:fillRef idx="1">
-            <a:schemeClr val="accent1"/>
-          </a:fillRef>
-          <a:effectRef idx="0">
-            <a:schemeClr val="accent1"/>
-          </a:effectRef>
-          <a:fontRef idx="minor"/>
-        </p:style>
-        <p:txBody>
-          <a:bodyPr lIns="56250" tIns="28125" rIns="56250" bIns="28125" anchor="ctr">
-            <a:noAutofit/>
-          </a:bodyPr>
-          <a:lstStyle/>
-          <a:p>
-            <a:pPr algn="ctr"/>
-            <a:r>
-              <a:rPr lang="en-US" sz="800" spc="-1" dirty="0">
-                <a:solidFill>
-                  <a:srgbClr val="FFFFFF"/>
-                </a:solidFill>
-                <a:latin typeface="Arial"/>
-              </a:rPr>
-              <a:t>ICSS EMAC</a:t>
-            </a:r>
-            <a:endParaRPr lang="en-IN" sz="800" spc="-1" dirty="0">
-              <a:solidFill>
-                <a:srgbClr val="FFFFFF"/>
-              </a:solidFill>
-              <a:latin typeface="Arial"/>
-            </a:endParaRPr>
-          </a:p>
-        </p:txBody>
-      </p:sp>
-    </p:spTree>
-    <p:extLst>
-      <p:ext uri="{BB962C8B-B14F-4D97-AF65-F5344CB8AC3E}">
-        <p14:creationId xmlns:p14="http://schemas.microsoft.com/office/powerpoint/2010/main" val="1537962718"/>
-      </p:ext>
-    </p:extLst>
-  </p:cSld>
-  <p:clrMapOvr>
-    <a:masterClrMapping/>
-  </p:clrMapOvr>
-</p:sld>
-</file>
-
-<file path=ppt/slides/slide5.xml><?xml version="1.0" encoding="utf-8"?>
 <p:sld xmlns:a="http://schemas.openxmlformats.org/drawingml/2006/main" xmlns:r="http://schemas.openxmlformats.org/officeDocument/2006/relationships" xmlns:p="http://schemas.openxmlformats.org/presentationml/2006/main">
   <p:cSld>
     <p:spTree>

</xml_diff>

<commit_message>
am263x/am263px: docs: update SDK block diagram
- update the SDK block diagram to reflect current SDK status

Fixes: PINDSW-8335

Signed-off-by: Archit Dev <a-dev@ti.com>
</commit_message>
<xml_diff>
--- a/docs_src/docs/api_guide/images/images.pptx
+++ b/docs_src/docs/api_guide/images/images.pptx
@@ -255,7 +255,7 @@
           <a:p>
             <a:fld id="{4ADF24D4-082E-4F97-B9C4-E0764843ED08}" type="datetimeFigureOut">
               <a:rPr lang="en-US" smtClean="0"/>
-              <a:t>12/20/2024</a:t>
+              <a:t>1/3/2025</a:t>
             </a:fld>
             <a:endParaRPr lang="en-US"/>
           </a:p>
@@ -7464,8 +7464,8 @@
         </p:nvSpPr>
         <p:spPr>
           <a:xfrm>
-            <a:off x="1792274" y="2976642"/>
-            <a:ext cx="3326914" cy="666000"/>
+            <a:off x="1017638" y="2976642"/>
+            <a:ext cx="4101550" cy="666000"/>
           </a:xfrm>
           <a:prstGeom prst="rect">
             <a:avLst/>
@@ -7922,8 +7922,8 @@
         </p:nvSpPr>
         <p:spPr>
           <a:xfrm>
-            <a:off x="1792273" y="1913489"/>
-            <a:ext cx="3326915" cy="464024"/>
+            <a:off x="1017639" y="1914803"/>
+            <a:ext cx="4101549" cy="462709"/>
           </a:xfrm>
           <a:prstGeom prst="rect">
             <a:avLst/>
@@ -7970,7 +7970,7 @@
                 <a:latin typeface="Arial"/>
                 <a:ea typeface="DejaVu Sans"/>
               </a:rPr>
-              <a:t>Protocol stacks</a:t>
+              <a:t>Protocol Stacks</a:t>
             </a:r>
             <a:endParaRPr lang="en-IN" sz="1125" spc="-1" dirty="0">
               <a:latin typeface="Arial"/>
@@ -7991,7 +7991,7 @@
                 <a:latin typeface="Arial"/>
                 <a:ea typeface="DejaVu Sans"/>
               </a:rPr>
-              <a:t>And Middleware</a:t>
+              <a:t>and Middleware</a:t>
             </a:r>
             <a:endParaRPr lang="en-IN" sz="1125" spc="-1" dirty="0">
               <a:latin typeface="Arial"/>
@@ -8013,8 +8013,8 @@
         </p:nvSpPr>
         <p:spPr>
           <a:xfrm>
-            <a:off x="1792274" y="2443091"/>
-            <a:ext cx="3326915" cy="461326"/>
+            <a:off x="1017640" y="2438074"/>
+            <a:ext cx="4101550" cy="466343"/>
           </a:xfrm>
           <a:prstGeom prst="rect">
             <a:avLst/>
@@ -8054,7 +8054,7 @@
               <a:buNone/>
             </a:pPr>
             <a:r>
-              <a:rPr lang="en-US" sz="1125" spc="-1">
+              <a:rPr lang="en-US" sz="1125" spc="-1" dirty="0">
                 <a:solidFill>
                   <a:srgbClr val="000000"/>
                 </a:solidFill>
@@ -8063,7 +8063,7 @@
               </a:rPr>
               <a:t>Drivers and</a:t>
             </a:r>
-            <a:endParaRPr lang="en-IN" sz="1125" spc="-1">
+            <a:endParaRPr lang="en-IN" sz="1125" spc="-1" dirty="0">
               <a:latin typeface="Arial"/>
             </a:endParaRPr>
           </a:p>
@@ -8075,7 +8075,7 @@
               <a:buNone/>
             </a:pPr>
             <a:r>
-              <a:rPr lang="en-US" sz="1125" spc="-1">
+              <a:rPr lang="en-US" sz="1125" spc="-1" dirty="0">
                 <a:solidFill>
                   <a:srgbClr val="000000"/>
                 </a:solidFill>
@@ -8084,7 +8084,7 @@
               </a:rPr>
               <a:t>HAL</a:t>
             </a:r>
-            <a:endParaRPr lang="en-IN" sz="1125" spc="-1">
+            <a:endParaRPr lang="en-IN" sz="1125" spc="-1" dirty="0">
               <a:latin typeface="Arial"/>
             </a:endParaRPr>
           </a:p>
@@ -8177,8 +8177,8 @@
         </p:nvSpPr>
         <p:spPr>
           <a:xfrm>
-            <a:off x="1792275" y="1378555"/>
-            <a:ext cx="3326913" cy="464024"/>
+            <a:off x="1017639" y="1378554"/>
+            <a:ext cx="4101549" cy="464025"/>
           </a:xfrm>
           <a:prstGeom prst="rect">
             <a:avLst/>
@@ -8249,7 +8249,7 @@
                 <a:latin typeface="Arial"/>
                 <a:ea typeface="DejaVu Sans"/>
               </a:rPr>
-              <a:t>And Demos</a:t>
+              <a:t>and Demos</a:t>
             </a:r>
             <a:endParaRPr lang="en-IN" sz="1125" spc="-1" dirty="0">
               <a:latin typeface="Arial"/>
@@ -8633,8 +8633,8 @@
         </p:nvSpPr>
         <p:spPr>
           <a:xfrm>
-            <a:off x="1792272" y="3695067"/>
-            <a:ext cx="3352381" cy="335592"/>
+            <a:off x="1017638" y="3695067"/>
+            <a:ext cx="4127015" cy="335592"/>
           </a:xfrm>
           <a:prstGeom prst="rect">
             <a:avLst/>
@@ -9134,7 +9134,7 @@
         </p:nvSpPr>
         <p:spPr>
           <a:xfrm>
-            <a:off x="3293133" y="4173098"/>
+            <a:off x="3225878" y="4173098"/>
             <a:ext cx="1114010" cy="335592"/>
           </a:xfrm>
           <a:prstGeom prst="rect">
@@ -9210,7 +9210,7 @@
         </p:nvSpPr>
         <p:spPr>
           <a:xfrm>
-            <a:off x="4773905" y="4173098"/>
+            <a:off x="4460875" y="4173098"/>
             <a:ext cx="1114010" cy="335592"/>
           </a:xfrm>
           <a:prstGeom prst="rect">
@@ -9495,7 +9495,7 @@
             <a:avLst/>
           </a:prstGeom>
           <a:solidFill>
-            <a:srgbClr val="92D050"/>
+            <a:srgbClr val="808080"/>
           </a:solidFill>
           <a:ln>
             <a:noFill/>
@@ -9531,26 +9531,17 @@
             <a:pPr algn="ctr"/>
             <a:r>
               <a:rPr lang="en-US" sz="800" spc="-1" dirty="0">
-                <a:latin typeface="Arial"/>
-              </a:rPr>
-              <a:t>ICSS</a:t>
-            </a:r>
-            <a:r>
-              <a:rPr lang="en-US" sz="800" spc="-1" dirty="0">
-                <a:solidFill>
-                  <a:srgbClr val="FFFFFF"/>
-                </a:solidFill>
-                <a:latin typeface="Arial"/>
-              </a:rPr>
-              <a:t> </a:t>
-            </a:r>
-            <a:r>
-              <a:rPr lang="en-US" sz="800" spc="-1" dirty="0">
-                <a:latin typeface="Arial"/>
-              </a:rPr>
-              <a:t>EMAC</a:t>
+                <a:solidFill>
+                  <a:srgbClr val="F6F6F6"/>
+                </a:solidFill>
+                <a:latin typeface="Arial"/>
+              </a:rPr>
+              <a:t>ICSS EMAC</a:t>
             </a:r>
             <a:endParaRPr lang="en-IN" sz="800" spc="-1" dirty="0">
+              <a:solidFill>
+                <a:srgbClr val="F6F6F6"/>
+              </a:solidFill>
               <a:latin typeface="Arial"/>
             </a:endParaRPr>
           </a:p>
@@ -10134,7 +10125,7 @@
                 <a:latin typeface="Arial"/>
                 <a:ea typeface="DejaVu Sans"/>
               </a:rPr>
-              <a:t>Protocol stacks</a:t>
+              <a:t>Protocol Stacks</a:t>
             </a:r>
             <a:endParaRPr lang="en-IN" sz="1125" spc="-1" dirty="0">
               <a:latin typeface="Arial"/>
@@ -10155,7 +10146,7 @@
                 <a:latin typeface="Arial"/>
                 <a:ea typeface="DejaVu Sans"/>
               </a:rPr>
-              <a:t>And Middleware</a:t>
+              <a:t>and Middleware</a:t>
             </a:r>
             <a:endParaRPr lang="en-IN" sz="1125" spc="-1" dirty="0">
               <a:latin typeface="Arial"/>
@@ -11835,17 +11826,17 @@
               <a:buNone/>
             </a:pPr>
             <a:r>
-              <a:rPr lang="en-US" sz="1125" spc="-1" dirty="0">
+              <a:rPr lang="en-US" sz="1125" spc="-1">
                 <a:solidFill>
                   <a:srgbClr val="000000"/>
                 </a:solidFill>
                 <a:latin typeface="Arial"/>
                 <a:ea typeface="DejaVu Sans"/>
               </a:rPr>
-              <a:t>And</a:t>
-            </a:r>
-            <a:r>
-              <a:rPr lang="en-IN" sz="1125" spc="-1" dirty="0">
+              <a:t>and</a:t>
+            </a:r>
+            <a:r>
+              <a:rPr lang="en-IN" sz="1125" spc="-1">
                 <a:latin typeface="Arial"/>
               </a:rPr>
               <a:t> </a:t>

</xml_diff>